<commit_message>
docs: update README and business proposal with offer engine and all v1.4 features
- README: add Offer Engine section (push+pull delivery, all 6 signal→offer mappings,
  deduplication), signal firing expiry table, WEBHOOK_OFFERS_URL env var, full demo
  walkthrough per signal, Demo Guide mention, updated Railway deploy instructions
  (migrate.ts now auto-runs schema+seed+subscriptions — no manual psql needed)
- PowerPoint: rename Opportunity → Offer Unlocked in signals table, update
  Operationalization slide to reference built-in Offer Engine subscriber, add new
  Slide 9 (Offer Engine — push/pull model, offer-per-signal table), update Demo
  site descriptions with offer/discount context, renumber to 13 slides total

Co-Authored-By: Claude Sonnet 4.6 <noreply@anthropic.com>
</commit_message>
<xml_diff>
--- a/docs/business-proposal.pptx
+++ b/docs/business-proposal.pptx
@@ -17,9 +17,10 @@
     <p:sldId id="265" r:id="rId11"/>
     <p:sldId id="266" r:id="rId12"/>
     <p:sldId id="267" r:id="rId13"/>
+    <p:sldId id="268" r:id="rId14"/>
   </p:sldIdLst>
   <p:notesMasterIdLst>
-    <p:notesMasterId r:id="rId14"/>
+    <p:notesMasterId r:id="rId15"/>
   </p:notesMasterIdLst>
   <p:sldSz cx="9144000" cy="5143500"/>
   <p:notesSz cx="5143500" cy="9144000"/>
@@ -819,6 +820,94 @@
 </p:notes>
 </file>
 
+<file path=ppt/notesSlides/notesSlide13.xml><?xml version="1.0" encoding="utf-8"?>
+<p:notes xmlns:a="http://schemas.openxmlformats.org/drawingml/2006/main" xmlns:r="http://schemas.openxmlformats.org/officeDocument/2006/relationships" xmlns:p="http://schemas.openxmlformats.org/presentationml/2006/main">
+  <p:cSld>
+    <p:spTree>
+      <p:nvGrpSpPr>
+        <p:cNvPr id="1" name=""/>
+        <p:cNvGrpSpPr/>
+        <p:nvPr/>
+      </p:nvGrpSpPr>
+      <p:grpSpPr>
+        <a:xfrm>
+          <a:off x="0" y="0"/>
+          <a:ext cx="0" cy="0"/>
+          <a:chOff x="0" y="0"/>
+          <a:chExt cx="0" cy="0"/>
+        </a:xfrm>
+      </p:grpSpPr>
+      <p:sp>
+        <p:nvSpPr>
+          <p:cNvPr id="2" name="Slide Image Placeholder 1"/>
+          <p:cNvSpPr>
+            <a:spLocks noGrp="1" noRot="1" noChangeAspect="1"/>
+          </p:cNvSpPr>
+          <p:nvPr>
+            <p:ph type="sldImg"/>
+          </p:nvPr>
+        </p:nvSpPr>
+        <p:spPr/>
+      </p:sp>
+      <p:sp>
+        <p:nvSpPr>
+          <p:cNvPr id="3" name="Notes Placeholder 2"/>
+          <p:cNvSpPr>
+            <a:spLocks noGrp="1"/>
+          </p:cNvSpPr>
+          <p:nvPr>
+            <p:ph type="body" idx="1"/>
+          </p:nvPr>
+        </p:nvSpPr>
+        <p:spPr/>
+        <p:txBody>
+          <a:bodyPr/>
+          <a:lstStyle/>
+          <a:p>
+            <a:r>
+              <a:rPr lang="en-US" dirty="0"/>
+              <a:t/>
+            </a:r>
+            <a:endParaRPr lang="en-US" dirty="0"/>
+          </a:p>
+        </p:txBody>
+      </p:sp>
+      <p:sp>
+        <p:nvSpPr>
+          <p:cNvPr id="4" name="Slide Number Placeholder 3"/>
+          <p:cNvSpPr>
+            <a:spLocks noGrp="1"/>
+          </p:cNvSpPr>
+          <p:nvPr>
+            <p:ph type="sldNum" sz="quarter" idx="10"/>
+          </p:nvPr>
+        </p:nvSpPr>
+        <p:spPr/>
+        <p:txBody>
+          <a:bodyPr/>
+          <a:lstStyle/>
+          <a:p>
+            <a:fld id="{F7021451-1387-4CA6-816F-3879F97B5CBC}" type="slidenum">
+              <a:rPr lang="en-US"/>
+              <a:t>13</a:t>
+            </a:fld>
+            <a:endParaRPr lang="en-US"/>
+          </a:p>
+        </p:txBody>
+      </p:sp>
+    </p:spTree>
+    <p:extLst>
+      <p:ext uri="{BB962C8B-B14F-4D97-AF65-F5344CB8AC3E}">
+        <p14:creationId xmlns:p14="http://schemas.microsoft.com/office/powerpoint/2010/main" val="1024086991"/>
+      </p:ext>
+    </p:extLst>
+  </p:cSld>
+  <p:clrMapOvr>
+    <a:masterClrMapping/>
+  </p:clrMapOvr>
+</p:notes>
+</file>
+
 <file path=ppt/notesSlides/notesSlide2.xml><?xml version="1.0" encoding="utf-8"?>
 <p:notes xmlns:a="http://schemas.openxmlformats.org/drawingml/2006/main" xmlns:r="http://schemas.openxmlformats.org/officeDocument/2006/relationships" xmlns:p="http://schemas.openxmlformats.org/presentationml/2006/main">
   <p:cSld>
@@ -2264,6 +2353,1210 @@
     <p:bg>
       <p:bgPr>
         <a:solidFill>
+          <a:srgbClr val="F8FAFC"/>
+        </a:solidFill>
+      </p:bgPr>
+    </p:bg>
+    <p:spTree>
+      <p:nvGrpSpPr>
+        <p:cNvPr id="1" name=""/>
+        <p:cNvGrpSpPr/>
+        <p:nvPr/>
+      </p:nvGrpSpPr>
+      <p:grpSpPr>
+        <a:xfrm>
+          <a:off x="0" y="0"/>
+          <a:ext cx="0" cy="0"/>
+          <a:chOff x="0" y="0"/>
+          <a:chExt cx="0" cy="0"/>
+        </a:xfrm>
+      </p:grpSpPr>
+      <p:sp>
+        <p:nvSpPr>
+          <p:cNvPr id="2" name="Text 0"/>
+          <p:cNvSpPr/>
+          <p:nvPr/>
+        </p:nvSpPr>
+        <p:spPr>
+          <a:xfrm>
+            <a:off x="457200" y="256032"/>
+            <a:ext cx="8229600" cy="475488"/>
+          </a:xfrm>
+          <a:prstGeom prst="rect">
+            <a:avLst/>
+          </a:prstGeom>
+          <a:noFill/>
+          <a:ln/>
+        </p:spPr>
+        <p:txBody>
+          <a:bodyPr wrap="square" lIns="0" tIns="0" rIns="0" bIns="0" rtlCol="0" anchor="ctr"/>
+          <a:lstStyle/>
+          <a:p>
+            <a:pPr indent="0" marL="0">
+              <a:buNone/>
+            </a:pPr>
+            <a:r>
+              <a:rPr lang="en-US" sz="2600" b="1" dirty="0">
+                <a:solidFill>
+                  <a:srgbClr val="0F172A"/>
+                </a:solidFill>
+                <a:latin typeface="Calibri" pitchFamily="34" charset="0"/>
+                <a:ea typeface="Calibri" pitchFamily="34" charset="-122"/>
+                <a:cs typeface="Calibri" pitchFamily="34" charset="-120"/>
+              </a:rPr>
+              <a:t>See It Live: The Apex Motors Story</a:t>
+            </a:r>
+            <a:endParaRPr lang="en-US" sz="2600" dirty="0"/>
+          </a:p>
+        </p:txBody>
+      </p:sp>
+      <p:sp>
+        <p:nvSpPr>
+          <p:cNvPr id="3" name="Shape 1"/>
+          <p:cNvSpPr/>
+          <p:nvPr/>
+        </p:nvSpPr>
+        <p:spPr>
+          <a:xfrm>
+            <a:off x="365760" y="1005840"/>
+            <a:ext cx="4114800" cy="1600200"/>
+          </a:xfrm>
+          <a:prstGeom prst="rect">
+            <a:avLst/>
+          </a:prstGeom>
+          <a:solidFill>
+            <a:srgbClr val="FFFFFF"/>
+          </a:solidFill>
+          <a:ln w="19050">
+            <a:solidFill>
+              <a:srgbClr val="6366F1"/>
+            </a:solidFill>
+            <a:prstDash val="solid"/>
+          </a:ln>
+          <a:effectLst>
+            <a:outerShdw sx="100000" sy="100000" kx="0" ky="0" algn="bl" rotWithShape="0" blurRad="101600" dist="38100" dir="8100000">
+              <a:srgbClr val="000000">
+                <a:alpha val="25000"/>
+              </a:srgbClr>
+            </a:outerShdw>
+          </a:effectLst>
+        </p:spPr>
+      </p:sp>
+      <p:sp>
+        <p:nvSpPr>
+          <p:cNvPr id="4" name="Shape 2"/>
+          <p:cNvSpPr/>
+          <p:nvPr/>
+        </p:nvSpPr>
+        <p:spPr>
+          <a:xfrm>
+            <a:off x="365760" y="1005840"/>
+            <a:ext cx="4114800" cy="91440"/>
+          </a:xfrm>
+          <a:prstGeom prst="rect">
+            <a:avLst/>
+          </a:prstGeom>
+          <a:solidFill>
+            <a:srgbClr val="6366F1"/>
+          </a:solidFill>
+          <a:ln w="12700">
+            <a:solidFill>
+              <a:srgbClr val="6366F1"/>
+            </a:solidFill>
+            <a:prstDash val="solid"/>
+          </a:ln>
+        </p:spPr>
+      </p:sp>
+      <p:sp>
+        <p:nvSpPr>
+          <p:cNvPr id="5" name="Shape 3"/>
+          <p:cNvSpPr/>
+          <p:nvPr/>
+        </p:nvSpPr>
+        <p:spPr>
+          <a:xfrm>
+            <a:off x="502920" y="1188720"/>
+            <a:ext cx="384048" cy="384048"/>
+          </a:xfrm>
+          <a:prstGeom prst="ellipse">
+            <a:avLst/>
+          </a:prstGeom>
+          <a:solidFill>
+            <a:srgbClr val="6366F1"/>
+          </a:solidFill>
+          <a:ln w="12700">
+            <a:solidFill>
+              <a:srgbClr val="6366F1"/>
+            </a:solidFill>
+            <a:prstDash val="solid"/>
+          </a:ln>
+        </p:spPr>
+      </p:sp>
+      <p:sp>
+        <p:nvSpPr>
+          <p:cNvPr id="6" name="Text 4"/>
+          <p:cNvSpPr/>
+          <p:nvPr/>
+        </p:nvSpPr>
+        <p:spPr>
+          <a:xfrm>
+            <a:off x="502920" y="1188720"/>
+            <a:ext cx="384048" cy="384048"/>
+          </a:xfrm>
+          <a:prstGeom prst="rect">
+            <a:avLst/>
+          </a:prstGeom>
+          <a:noFill/>
+          <a:ln/>
+        </p:spPr>
+        <p:txBody>
+          <a:bodyPr wrap="square" lIns="0" tIns="0" rIns="0" bIns="0" rtlCol="0" anchor="ctr"/>
+          <a:lstStyle/>
+          <a:p>
+            <a:pPr algn="ctr" indent="0" marL="0">
+              <a:buNone/>
+            </a:pPr>
+            <a:r>
+              <a:rPr lang="en-US" sz="750" b="1" dirty="0">
+                <a:solidFill>
+                  <a:srgbClr val="FFFFFF"/>
+                </a:solidFill>
+                <a:latin typeface="Calibri" pitchFamily="34" charset="0"/>
+                <a:ea typeface="Calibri" pitchFamily="34" charset="-122"/>
+                <a:cs typeface="Calibri" pitchFamily="34" charset="-120"/>
+              </a:rPr>
+              <a:t>Site A</a:t>
+            </a:r>
+            <a:endParaRPr lang="en-US" sz="750" dirty="0"/>
+          </a:p>
+        </p:txBody>
+      </p:sp>
+      <p:sp>
+        <p:nvSpPr>
+          <p:cNvPr id="7" name="Text 5"/>
+          <p:cNvSpPr/>
+          <p:nvPr/>
+        </p:nvSpPr>
+        <p:spPr>
+          <a:xfrm>
+            <a:off x="960120" y="1188720"/>
+            <a:ext cx="3383280" cy="384048"/>
+          </a:xfrm>
+          <a:prstGeom prst="rect">
+            <a:avLst/>
+          </a:prstGeom>
+          <a:noFill/>
+          <a:ln/>
+        </p:spPr>
+        <p:txBody>
+          <a:bodyPr wrap="square" lIns="0" tIns="0" rIns="0" bIns="0" rtlCol="0" anchor="ctr"/>
+          <a:lstStyle/>
+          <a:p>
+            <a:pPr indent="0" marL="0">
+              <a:buNone/>
+            </a:pPr>
+            <a:r>
+              <a:rPr lang="en-US" sz="1300" b="1" dirty="0">
+                <a:solidFill>
+                  <a:srgbClr val="0F172A"/>
+                </a:solidFill>
+                <a:latin typeface="Calibri" pitchFamily="34" charset="0"/>
+                <a:ea typeface="Calibri" pitchFamily="34" charset="-122"/>
+                <a:cs typeface="Calibri" pitchFamily="34" charset="-120"/>
+              </a:rPr>
+              <a:t>🏎️  Apex Motors Storefront</a:t>
+            </a:r>
+            <a:endParaRPr lang="en-US" sz="1300" dirty="0"/>
+          </a:p>
+        </p:txBody>
+      </p:sp>
+      <p:sp>
+        <p:nvSpPr>
+          <p:cNvPr id="8" name="Text 6"/>
+          <p:cNvSpPr/>
+          <p:nvPr/>
+        </p:nvSpPr>
+        <p:spPr>
+          <a:xfrm>
+            <a:off x="960120" y="1572768"/>
+            <a:ext cx="3383280" cy="256032"/>
+          </a:xfrm>
+          <a:prstGeom prst="rect">
+            <a:avLst/>
+          </a:prstGeom>
+          <a:noFill/>
+          <a:ln/>
+        </p:spPr>
+        <p:txBody>
+          <a:bodyPr wrap="square" lIns="0" tIns="0" rIns="0" bIns="0" rtlCol="0" anchor="ctr"/>
+          <a:lstStyle/>
+          <a:p>
+            <a:pPr indent="0" marL="0">
+              <a:buNone/>
+            </a:pPr>
+            <a:r>
+              <a:rPr lang="en-US" sz="950" dirty="0">
+                <a:solidFill>
+                  <a:srgbClr val="6366F1"/>
+                </a:solidFill>
+                <a:latin typeface="Consolas" pitchFamily="34" charset="0"/>
+                <a:ea typeface="Consolas" pitchFamily="34" charset="-122"/>
+                <a:cs typeface="Consolas" pitchFamily="34" charset="-120"/>
+              </a:rPr>
+              <a:t>localhost:3001</a:t>
+            </a:r>
+            <a:endParaRPr lang="en-US" sz="950" dirty="0"/>
+          </a:p>
+        </p:txBody>
+      </p:sp>
+      <p:sp>
+        <p:nvSpPr>
+          <p:cNvPr id="9" name="Text 7"/>
+          <p:cNvSpPr/>
+          <p:nvPr/>
+        </p:nvSpPr>
+        <p:spPr>
+          <a:xfrm>
+            <a:off x="502920" y="1874520"/>
+            <a:ext cx="3840480" cy="594360"/>
+          </a:xfrm>
+          <a:prstGeom prst="rect">
+            <a:avLst/>
+          </a:prstGeom>
+          <a:noFill/>
+          <a:ln/>
+        </p:spPr>
+        <p:txBody>
+          <a:bodyPr wrap="square" lIns="0" tIns="0" rIns="0" bIns="0" rtlCol="0" anchor="ctr"/>
+          <a:lstStyle/>
+          <a:p>
+            <a:pPr indent="0" marL="0">
+              <a:buNone/>
+            </a:pPr>
+            <a:r>
+              <a:rPr lang="en-US" sz="1050" dirty="0">
+                <a:solidFill>
+                  <a:srgbClr val="475569"/>
+                </a:solidFill>
+                <a:latin typeface="Calibri" pitchFamily="34" charset="0"/>
+                <a:ea typeface="Calibri" pitchFamily="34" charset="-122"/>
+                <a:cs typeface="Calibri" pitchFamily="34" charset="-120"/>
+              </a:rPr>
+              <a:t>Browse vehicles — active High Purchase Intent offer shows gold discounted price with struck-through MSRP across all listings</a:t>
+            </a:r>
+            <a:endParaRPr lang="en-US" sz="1050" dirty="0"/>
+          </a:p>
+        </p:txBody>
+      </p:sp>
+      <p:sp>
+        <p:nvSpPr>
+          <p:cNvPr id="10" name="Shape 8"/>
+          <p:cNvSpPr/>
+          <p:nvPr/>
+        </p:nvSpPr>
+        <p:spPr>
+          <a:xfrm>
+            <a:off x="4663440" y="1005840"/>
+            <a:ext cx="4114800" cy="1600200"/>
+          </a:xfrm>
+          <a:prstGeom prst="rect">
+            <a:avLst/>
+          </a:prstGeom>
+          <a:solidFill>
+            <a:srgbClr val="FFFFFF"/>
+          </a:solidFill>
+          <a:ln w="19050">
+            <a:solidFill>
+              <a:srgbClr val="F59E0B"/>
+            </a:solidFill>
+            <a:prstDash val="solid"/>
+          </a:ln>
+          <a:effectLst>
+            <a:outerShdw sx="100000" sy="100000" kx="0" ky="0" algn="bl" rotWithShape="0" blurRad="101600" dist="38100" dir="8100000">
+              <a:srgbClr val="000000">
+                <a:alpha val="25000"/>
+              </a:srgbClr>
+            </a:outerShdw>
+          </a:effectLst>
+        </p:spPr>
+      </p:sp>
+      <p:sp>
+        <p:nvSpPr>
+          <p:cNvPr id="11" name="Shape 9"/>
+          <p:cNvSpPr/>
+          <p:nvPr/>
+        </p:nvSpPr>
+        <p:spPr>
+          <a:xfrm>
+            <a:off x="4663440" y="1005840"/>
+            <a:ext cx="4114800" cy="91440"/>
+          </a:xfrm>
+          <a:prstGeom prst="rect">
+            <a:avLst/>
+          </a:prstGeom>
+          <a:solidFill>
+            <a:srgbClr val="F59E0B"/>
+          </a:solidFill>
+          <a:ln w="12700">
+            <a:solidFill>
+              <a:srgbClr val="F59E0B"/>
+            </a:solidFill>
+            <a:prstDash val="solid"/>
+          </a:ln>
+        </p:spPr>
+      </p:sp>
+      <p:sp>
+        <p:nvSpPr>
+          <p:cNvPr id="12" name="Shape 10"/>
+          <p:cNvSpPr/>
+          <p:nvPr/>
+        </p:nvSpPr>
+        <p:spPr>
+          <a:xfrm>
+            <a:off x="4800600" y="1188720"/>
+            <a:ext cx="384048" cy="384048"/>
+          </a:xfrm>
+          <a:prstGeom prst="ellipse">
+            <a:avLst/>
+          </a:prstGeom>
+          <a:solidFill>
+            <a:srgbClr val="F59E0B"/>
+          </a:solidFill>
+          <a:ln w="12700">
+            <a:solidFill>
+              <a:srgbClr val="F59E0B"/>
+            </a:solidFill>
+            <a:prstDash val="solid"/>
+          </a:ln>
+        </p:spPr>
+      </p:sp>
+      <p:sp>
+        <p:nvSpPr>
+          <p:cNvPr id="13" name="Text 11"/>
+          <p:cNvSpPr/>
+          <p:nvPr/>
+        </p:nvSpPr>
+        <p:spPr>
+          <a:xfrm>
+            <a:off x="4800600" y="1188720"/>
+            <a:ext cx="384048" cy="384048"/>
+          </a:xfrm>
+          <a:prstGeom prst="rect">
+            <a:avLst/>
+          </a:prstGeom>
+          <a:noFill/>
+          <a:ln/>
+        </p:spPr>
+        <p:txBody>
+          <a:bodyPr wrap="square" lIns="0" tIns="0" rIns="0" bIns="0" rtlCol="0" anchor="ctr"/>
+          <a:lstStyle/>
+          <a:p>
+            <a:pPr algn="ctr" indent="0" marL="0">
+              <a:buNone/>
+            </a:pPr>
+            <a:r>
+              <a:rPr lang="en-US" sz="750" b="1" dirty="0">
+                <a:solidFill>
+                  <a:srgbClr val="FFFFFF"/>
+                </a:solidFill>
+                <a:latin typeface="Calibri" pitchFamily="34" charset="0"/>
+                <a:ea typeface="Calibri" pitchFamily="34" charset="-122"/>
+                <a:cs typeface="Calibri" pitchFamily="34" charset="-120"/>
+              </a:rPr>
+              <a:t>Site B</a:t>
+            </a:r>
+            <a:endParaRPr lang="en-US" sz="750" dirty="0"/>
+          </a:p>
+        </p:txBody>
+      </p:sp>
+      <p:sp>
+        <p:nvSpPr>
+          <p:cNvPr id="14" name="Text 12"/>
+          <p:cNvSpPr/>
+          <p:nvPr/>
+        </p:nvSpPr>
+        <p:spPr>
+          <a:xfrm>
+            <a:off x="5257800" y="1188720"/>
+            <a:ext cx="3383280" cy="384048"/>
+          </a:xfrm>
+          <a:prstGeom prst="rect">
+            <a:avLst/>
+          </a:prstGeom>
+          <a:noFill/>
+          <a:ln/>
+        </p:spPr>
+        <p:txBody>
+          <a:bodyPr wrap="square" lIns="0" tIns="0" rIns="0" bIns="0" rtlCol="0" anchor="ctr"/>
+          <a:lstStyle/>
+          <a:p>
+            <a:pPr indent="0" marL="0">
+              <a:buNone/>
+            </a:pPr>
+            <a:r>
+              <a:rPr lang="en-US" sz="1300" b="1" dirty="0">
+                <a:solidFill>
+                  <a:srgbClr val="0F172A"/>
+                </a:solidFill>
+                <a:latin typeface="Calibri" pitchFamily="34" charset="0"/>
+                <a:ea typeface="Calibri" pitchFamily="34" charset="-122"/>
+                <a:cs typeface="Calibri" pitchFamily="34" charset="-120"/>
+              </a:rPr>
+              <a:t>⭐  Apex Rewards Portal</a:t>
+            </a:r>
+            <a:endParaRPr lang="en-US" sz="1300" dirty="0"/>
+          </a:p>
+        </p:txBody>
+      </p:sp>
+      <p:sp>
+        <p:nvSpPr>
+          <p:cNvPr id="15" name="Text 13"/>
+          <p:cNvSpPr/>
+          <p:nvPr/>
+        </p:nvSpPr>
+        <p:spPr>
+          <a:xfrm>
+            <a:off x="5257800" y="1572768"/>
+            <a:ext cx="3383280" cy="256032"/>
+          </a:xfrm>
+          <a:prstGeom prst="rect">
+            <a:avLst/>
+          </a:prstGeom>
+          <a:noFill/>
+          <a:ln/>
+        </p:spPr>
+        <p:txBody>
+          <a:bodyPr wrap="square" lIns="0" tIns="0" rIns="0" bIns="0" rtlCol="0" anchor="ctr"/>
+          <a:lstStyle/>
+          <a:p>
+            <a:pPr indent="0" marL="0">
+              <a:buNone/>
+            </a:pPr>
+            <a:r>
+              <a:rPr lang="en-US" sz="950" dirty="0">
+                <a:solidFill>
+                  <a:srgbClr val="F59E0B"/>
+                </a:solidFill>
+                <a:latin typeface="Consolas" pitchFamily="34" charset="0"/>
+                <a:ea typeface="Consolas" pitchFamily="34" charset="-122"/>
+                <a:cs typeface="Consolas" pitchFamily="34" charset="-120"/>
+              </a:rPr>
+              <a:t>localhost:3002</a:t>
+            </a:r>
+            <a:endParaRPr lang="en-US" sz="950" dirty="0"/>
+          </a:p>
+        </p:txBody>
+      </p:sp>
+      <p:sp>
+        <p:nvSpPr>
+          <p:cNvPr id="16" name="Text 14"/>
+          <p:cNvSpPr/>
+          <p:nvPr/>
+        </p:nvSpPr>
+        <p:spPr>
+          <a:xfrm>
+            <a:off x="4800600" y="1874520"/>
+            <a:ext cx="3840480" cy="594360"/>
+          </a:xfrm>
+          <a:prstGeom prst="rect">
+            <a:avLst/>
+          </a:prstGeom>
+          <a:noFill/>
+          <a:ln/>
+        </p:spPr>
+        <p:txBody>
+          <a:bodyPr wrap="square" lIns="0" tIns="0" rIns="0" bIns="0" rtlCol="0" anchor="ctr"/>
+          <a:lstStyle/>
+          <a:p>
+            <a:pPr indent="0" marL="0">
+              <a:buNone/>
+            </a:pPr>
+            <a:r>
+              <a:rPr lang="en-US" sz="1050" dirty="0">
+                <a:solidFill>
+                  <a:srgbClr val="475569"/>
+                </a:solidFill>
+                <a:latin typeface="Calibri" pitchFamily="34" charset="0"/>
+                <a:ea typeface="Calibri" pitchFamily="34" charset="-122"/>
+                <a:cs typeface="Calibri" pitchFamily="34" charset="-120"/>
+              </a:rPr>
+              <a:t>Personalized offer cards appear in real time as signals fire — 6 signal types, live polling, no refresh needed</a:t>
+            </a:r>
+            <a:endParaRPr lang="en-US" sz="1050" dirty="0"/>
+          </a:p>
+        </p:txBody>
+      </p:sp>
+      <p:sp>
+        <p:nvSpPr>
+          <p:cNvPr id="17" name="Shape 15"/>
+          <p:cNvSpPr/>
+          <p:nvPr/>
+        </p:nvSpPr>
+        <p:spPr>
+          <a:xfrm>
+            <a:off x="365760" y="2788920"/>
+            <a:ext cx="4114800" cy="1600200"/>
+          </a:xfrm>
+          <a:prstGeom prst="rect">
+            <a:avLst/>
+          </a:prstGeom>
+          <a:solidFill>
+            <a:srgbClr val="FFFFFF"/>
+          </a:solidFill>
+          <a:ln w="19050">
+            <a:solidFill>
+              <a:srgbClr val="10B981"/>
+            </a:solidFill>
+            <a:prstDash val="solid"/>
+          </a:ln>
+          <a:effectLst>
+            <a:outerShdw sx="100000" sy="100000" kx="0" ky="0" algn="bl" rotWithShape="0" blurRad="101600" dist="38100" dir="8100000">
+              <a:srgbClr val="000000">
+                <a:alpha val="25000"/>
+              </a:srgbClr>
+            </a:outerShdw>
+          </a:effectLst>
+        </p:spPr>
+      </p:sp>
+      <p:sp>
+        <p:nvSpPr>
+          <p:cNvPr id="18" name="Shape 16"/>
+          <p:cNvSpPr/>
+          <p:nvPr/>
+        </p:nvSpPr>
+        <p:spPr>
+          <a:xfrm>
+            <a:off x="365760" y="2788920"/>
+            <a:ext cx="4114800" cy="91440"/>
+          </a:xfrm>
+          <a:prstGeom prst="rect">
+            <a:avLst/>
+          </a:prstGeom>
+          <a:solidFill>
+            <a:srgbClr val="10B981"/>
+          </a:solidFill>
+          <a:ln w="12700">
+            <a:solidFill>
+              <a:srgbClr val="10B981"/>
+            </a:solidFill>
+            <a:prstDash val="solid"/>
+          </a:ln>
+        </p:spPr>
+      </p:sp>
+      <p:sp>
+        <p:nvSpPr>
+          <p:cNvPr id="19" name="Shape 17"/>
+          <p:cNvSpPr/>
+          <p:nvPr/>
+        </p:nvSpPr>
+        <p:spPr>
+          <a:xfrm>
+            <a:off x="502920" y="2971800"/>
+            <a:ext cx="384048" cy="384048"/>
+          </a:xfrm>
+          <a:prstGeom prst="ellipse">
+            <a:avLst/>
+          </a:prstGeom>
+          <a:solidFill>
+            <a:srgbClr val="10B981"/>
+          </a:solidFill>
+          <a:ln w="12700">
+            <a:solidFill>
+              <a:srgbClr val="10B981"/>
+            </a:solidFill>
+            <a:prstDash val="solid"/>
+          </a:ln>
+        </p:spPr>
+      </p:sp>
+      <p:sp>
+        <p:nvSpPr>
+          <p:cNvPr id="20" name="Text 18"/>
+          <p:cNvSpPr/>
+          <p:nvPr/>
+        </p:nvSpPr>
+        <p:spPr>
+          <a:xfrm>
+            <a:off x="502920" y="2971800"/>
+            <a:ext cx="384048" cy="384048"/>
+          </a:xfrm>
+          <a:prstGeom prst="rect">
+            <a:avLst/>
+          </a:prstGeom>
+          <a:noFill/>
+          <a:ln/>
+        </p:spPr>
+        <p:txBody>
+          <a:bodyPr wrap="square" lIns="0" tIns="0" rIns="0" bIns="0" rtlCol="0" anchor="ctr"/>
+          <a:lstStyle/>
+          <a:p>
+            <a:pPr algn="ctr" indent="0" marL="0">
+              <a:buNone/>
+            </a:pPr>
+            <a:r>
+              <a:rPr lang="en-US" sz="750" b="1" dirty="0">
+                <a:solidFill>
+                  <a:srgbClr val="FFFFFF"/>
+                </a:solidFill>
+                <a:latin typeface="Calibri" pitchFamily="34" charset="0"/>
+                <a:ea typeface="Calibri" pitchFamily="34" charset="-122"/>
+                <a:cs typeface="Calibri" pitchFamily="34" charset="-120"/>
+              </a:rPr>
+              <a:t>Site C</a:t>
+            </a:r>
+            <a:endParaRPr lang="en-US" sz="750" dirty="0"/>
+          </a:p>
+        </p:txBody>
+      </p:sp>
+      <p:sp>
+        <p:nvSpPr>
+          <p:cNvPr id="21" name="Text 19"/>
+          <p:cNvSpPr/>
+          <p:nvPr/>
+        </p:nvSpPr>
+        <p:spPr>
+          <a:xfrm>
+            <a:off x="960120" y="2971800"/>
+            <a:ext cx="3383280" cy="384048"/>
+          </a:xfrm>
+          <a:prstGeom prst="rect">
+            <a:avLst/>
+          </a:prstGeom>
+          <a:noFill/>
+          <a:ln/>
+        </p:spPr>
+        <p:txBody>
+          <a:bodyPr wrap="square" lIns="0" tIns="0" rIns="0" bIns="0" rtlCol="0" anchor="ctr"/>
+          <a:lstStyle/>
+          <a:p>
+            <a:pPr indent="0" marL="0">
+              <a:buNone/>
+            </a:pPr>
+            <a:r>
+              <a:rPr lang="en-US" sz="1300" b="1" dirty="0">
+                <a:solidFill>
+                  <a:srgbClr val="0F172A"/>
+                </a:solidFill>
+                <a:latin typeface="Calibri" pitchFamily="34" charset="0"/>
+                <a:ea typeface="Calibri" pitchFamily="34" charset="-122"/>
+                <a:cs typeface="Calibri" pitchFamily="34" charset="-120"/>
+              </a:rPr>
+              <a:t>📡  Telemetry Simulator</a:t>
+            </a:r>
+            <a:endParaRPr lang="en-US" sz="1300" dirty="0"/>
+          </a:p>
+        </p:txBody>
+      </p:sp>
+      <p:sp>
+        <p:nvSpPr>
+          <p:cNvPr id="22" name="Text 20"/>
+          <p:cNvSpPr/>
+          <p:nvPr/>
+        </p:nvSpPr>
+        <p:spPr>
+          <a:xfrm>
+            <a:off x="960120" y="3355848"/>
+            <a:ext cx="3383280" cy="256032"/>
+          </a:xfrm>
+          <a:prstGeom prst="rect">
+            <a:avLst/>
+          </a:prstGeom>
+          <a:noFill/>
+          <a:ln/>
+        </p:spPr>
+        <p:txBody>
+          <a:bodyPr wrap="square" lIns="0" tIns="0" rIns="0" bIns="0" rtlCol="0" anchor="ctr"/>
+          <a:lstStyle/>
+          <a:p>
+            <a:pPr indent="0" marL="0">
+              <a:buNone/>
+            </a:pPr>
+            <a:r>
+              <a:rPr lang="en-US" sz="950" dirty="0">
+                <a:solidFill>
+                  <a:srgbClr val="10B981"/>
+                </a:solidFill>
+                <a:latin typeface="Consolas" pitchFamily="34" charset="0"/>
+                <a:ea typeface="Consolas" pitchFamily="34" charset="-122"/>
+                <a:cs typeface="Consolas" pitchFamily="34" charset="-120"/>
+              </a:rPr>
+              <a:t>localhost:3003</a:t>
+            </a:r>
+            <a:endParaRPr lang="en-US" sz="950" dirty="0"/>
+          </a:p>
+        </p:txBody>
+      </p:sp>
+      <p:sp>
+        <p:nvSpPr>
+          <p:cNvPr id="23" name="Text 21"/>
+          <p:cNvSpPr/>
+          <p:nvPr/>
+        </p:nvSpPr>
+        <p:spPr>
+          <a:xfrm>
+            <a:off x="502920" y="3657600"/>
+            <a:ext cx="3840480" cy="594360"/>
+          </a:xfrm>
+          <a:prstGeom prst="rect">
+            <a:avLst/>
+          </a:prstGeom>
+          <a:noFill/>
+          <a:ln/>
+        </p:spPr>
+        <p:txBody>
+          <a:bodyPr wrap="square" lIns="0" tIns="0" rIns="0" bIns="0" rtlCol="0" anchor="ctr"/>
+          <a:lstStyle/>
+          <a:p>
+            <a:pPr indent="0" marL="0">
+              <a:buNone/>
+            </a:pPr>
+            <a:r>
+              <a:rPr lang="en-US" sz="1050" dirty="0">
+                <a:solidFill>
+                  <a:srgbClr val="475569"/>
+                </a:solidFill>
+                <a:latin typeface="Calibri" pitchFamily="34" charset="0"/>
+                <a:ea typeface="Calibri" pitchFamily="34" charset="-122"/>
+                <a:cs typeface="Calibri" pitchFamily="34" charset="-120"/>
+              </a:rPr>
+              <a:t>Simulate car GPS drives, dealership check-ins, and rental events — fires signals from the physical world</a:t>
+            </a:r>
+            <a:endParaRPr lang="en-US" sz="1050" dirty="0"/>
+          </a:p>
+        </p:txBody>
+      </p:sp>
+      <p:sp>
+        <p:nvSpPr>
+          <p:cNvPr id="24" name="Shape 22"/>
+          <p:cNvSpPr/>
+          <p:nvPr/>
+        </p:nvSpPr>
+        <p:spPr>
+          <a:xfrm>
+            <a:off x="4663440" y="2788920"/>
+            <a:ext cx="4114800" cy="1600200"/>
+          </a:xfrm>
+          <a:prstGeom prst="rect">
+            <a:avLst/>
+          </a:prstGeom>
+          <a:solidFill>
+            <a:srgbClr val="FFFFFF"/>
+          </a:solidFill>
+          <a:ln w="19050">
+            <a:solidFill>
+              <a:srgbClr val="8B5CF6"/>
+            </a:solidFill>
+            <a:prstDash val="solid"/>
+          </a:ln>
+          <a:effectLst>
+            <a:outerShdw sx="100000" sy="100000" kx="0" ky="0" algn="bl" rotWithShape="0" blurRad="101600" dist="38100" dir="8100000">
+              <a:srgbClr val="000000">
+                <a:alpha val="25000"/>
+              </a:srgbClr>
+            </a:outerShdw>
+          </a:effectLst>
+        </p:spPr>
+      </p:sp>
+      <p:sp>
+        <p:nvSpPr>
+          <p:cNvPr id="25" name="Shape 23"/>
+          <p:cNvSpPr/>
+          <p:nvPr/>
+        </p:nvSpPr>
+        <p:spPr>
+          <a:xfrm>
+            <a:off x="4663440" y="2788920"/>
+            <a:ext cx="4114800" cy="91440"/>
+          </a:xfrm>
+          <a:prstGeom prst="rect">
+            <a:avLst/>
+          </a:prstGeom>
+          <a:solidFill>
+            <a:srgbClr val="8B5CF6"/>
+          </a:solidFill>
+          <a:ln w="12700">
+            <a:solidFill>
+              <a:srgbClr val="8B5CF6"/>
+            </a:solidFill>
+            <a:prstDash val="solid"/>
+          </a:ln>
+        </p:spPr>
+      </p:sp>
+      <p:sp>
+        <p:nvSpPr>
+          <p:cNvPr id="26" name="Shape 24"/>
+          <p:cNvSpPr/>
+          <p:nvPr/>
+        </p:nvSpPr>
+        <p:spPr>
+          <a:xfrm>
+            <a:off x="4800600" y="2971800"/>
+            <a:ext cx="384048" cy="384048"/>
+          </a:xfrm>
+          <a:prstGeom prst="ellipse">
+            <a:avLst/>
+          </a:prstGeom>
+          <a:solidFill>
+            <a:srgbClr val="8B5CF6"/>
+          </a:solidFill>
+          <a:ln w="12700">
+            <a:solidFill>
+              <a:srgbClr val="8B5CF6"/>
+            </a:solidFill>
+            <a:prstDash val="solid"/>
+          </a:ln>
+        </p:spPr>
+      </p:sp>
+      <p:sp>
+        <p:nvSpPr>
+          <p:cNvPr id="27" name="Text 25"/>
+          <p:cNvSpPr/>
+          <p:nvPr/>
+        </p:nvSpPr>
+        <p:spPr>
+          <a:xfrm>
+            <a:off x="4800600" y="2971800"/>
+            <a:ext cx="384048" cy="384048"/>
+          </a:xfrm>
+          <a:prstGeom prst="rect">
+            <a:avLst/>
+          </a:prstGeom>
+          <a:noFill/>
+          <a:ln/>
+        </p:spPr>
+        <p:txBody>
+          <a:bodyPr wrap="square" lIns="0" tIns="0" rIns="0" bIns="0" rtlCol="0" anchor="ctr"/>
+          <a:lstStyle/>
+          <a:p>
+            <a:pPr algn="ctr" indent="0" marL="0">
+              <a:buNone/>
+            </a:pPr>
+            <a:r>
+              <a:rPr lang="en-US" sz="750" b="1" dirty="0">
+                <a:solidFill>
+                  <a:srgbClr val="FFFFFF"/>
+                </a:solidFill>
+                <a:latin typeface="Calibri" pitchFamily="34" charset="0"/>
+                <a:ea typeface="Calibri" pitchFamily="34" charset="-122"/>
+                <a:cs typeface="Calibri" pitchFamily="34" charset="-120"/>
+              </a:rPr>
+              <a:t>Site D</a:t>
+            </a:r>
+            <a:endParaRPr lang="en-US" sz="750" dirty="0"/>
+          </a:p>
+        </p:txBody>
+      </p:sp>
+      <p:sp>
+        <p:nvSpPr>
+          <p:cNvPr id="28" name="Text 26"/>
+          <p:cNvSpPr/>
+          <p:nvPr/>
+        </p:nvSpPr>
+        <p:spPr>
+          <a:xfrm>
+            <a:off x="5257800" y="2971800"/>
+            <a:ext cx="3383280" cy="384048"/>
+          </a:xfrm>
+          <a:prstGeom prst="rect">
+            <a:avLst/>
+          </a:prstGeom>
+          <a:noFill/>
+          <a:ln/>
+        </p:spPr>
+        <p:txBody>
+          <a:bodyPr wrap="square" lIns="0" tIns="0" rIns="0" bIns="0" rtlCol="0" anchor="ctr"/>
+          <a:lstStyle/>
+          <a:p>
+            <a:pPr indent="0" marL="0">
+              <a:buNone/>
+            </a:pPr>
+            <a:r>
+              <a:rPr lang="en-US" sz="1300" b="1" dirty="0">
+                <a:solidFill>
+                  <a:srgbClr val="0F172A"/>
+                </a:solidFill>
+                <a:latin typeface="Calibri" pitchFamily="34" charset="0"/>
+                <a:ea typeface="Calibri" pitchFamily="34" charset="-122"/>
+                <a:cs typeface="Calibri" pitchFamily="34" charset="-120"/>
+              </a:rPr>
+              <a:t>🖥️  Nexus CDP Platform</a:t>
+            </a:r>
+            <a:endParaRPr lang="en-US" sz="1300" dirty="0"/>
+          </a:p>
+        </p:txBody>
+      </p:sp>
+      <p:sp>
+        <p:nvSpPr>
+          <p:cNvPr id="29" name="Text 27"/>
+          <p:cNvSpPr/>
+          <p:nvPr/>
+        </p:nvSpPr>
+        <p:spPr>
+          <a:xfrm>
+            <a:off x="5257800" y="3355848"/>
+            <a:ext cx="3383280" cy="256032"/>
+          </a:xfrm>
+          <a:prstGeom prst="rect">
+            <a:avLst/>
+          </a:prstGeom>
+          <a:noFill/>
+          <a:ln/>
+        </p:spPr>
+        <p:txBody>
+          <a:bodyPr wrap="square" lIns="0" tIns="0" rIns="0" bIns="0" rtlCol="0" anchor="ctr"/>
+          <a:lstStyle/>
+          <a:p>
+            <a:pPr indent="0" marL="0">
+              <a:buNone/>
+            </a:pPr>
+            <a:r>
+              <a:rPr lang="en-US" sz="950" dirty="0">
+                <a:solidFill>
+                  <a:srgbClr val="8B5CF6"/>
+                </a:solidFill>
+                <a:latin typeface="Consolas" pitchFamily="34" charset="0"/>
+                <a:ea typeface="Consolas" pitchFamily="34" charset="-122"/>
+                <a:cs typeface="Consolas" pitchFamily="34" charset="-120"/>
+              </a:rPr>
+              <a:t>localhost:3004</a:t>
+            </a:r>
+            <a:endParaRPr lang="en-US" sz="950" dirty="0"/>
+          </a:p>
+        </p:txBody>
+      </p:sp>
+      <p:sp>
+        <p:nvSpPr>
+          <p:cNvPr id="30" name="Text 28"/>
+          <p:cNvSpPr/>
+          <p:nvPr/>
+        </p:nvSpPr>
+        <p:spPr>
+          <a:xfrm>
+            <a:off x="4800600" y="3657600"/>
+            <a:ext cx="3840480" cy="594360"/>
+          </a:xfrm>
+          <a:prstGeom prst="rect">
+            <a:avLst/>
+          </a:prstGeom>
+          <a:noFill/>
+          <a:ln/>
+        </p:spPr>
+        <p:txBody>
+          <a:bodyPr wrap="square" lIns="0" tIns="0" rIns="0" bIns="0" rtlCol="0" anchor="ctr"/>
+          <a:lstStyle/>
+          <a:p>
+            <a:pPr indent="0" marL="0">
+              <a:buNone/>
+            </a:pPr>
+            <a:r>
+              <a:rPr lang="en-US" sz="1050" dirty="0">
+                <a:solidFill>
+                  <a:srgbClr val="475569"/>
+                </a:solidFill>
+                <a:latin typeface="Calibri" pitchFamily="34" charset="0"/>
+                <a:ea typeface="Calibri" pitchFamily="34" charset="-122"/>
+                <a:cs typeface="Calibri" pitchFamily="34" charset="-120"/>
+              </a:rPr>
+              <a:t>Profiles, live event stream, signal builder, webhook delivery log, and Demo Guide with step-by-step trigger instructions</a:t>
+            </a:r>
+            <a:endParaRPr lang="en-US" sz="1050" dirty="0"/>
+          </a:p>
+        </p:txBody>
+      </p:sp>
+      <p:sp>
+        <p:nvSpPr>
+          <p:cNvPr id="31" name="Text 29"/>
+          <p:cNvSpPr/>
+          <p:nvPr/>
+        </p:nvSpPr>
+        <p:spPr>
+          <a:xfrm>
+            <a:off x="365760" y="4553712"/>
+            <a:ext cx="8412480" cy="320040"/>
+          </a:xfrm>
+          <a:prstGeom prst="rect">
+            <a:avLst/>
+          </a:prstGeom>
+          <a:noFill/>
+          <a:ln/>
+        </p:spPr>
+        <p:txBody>
+          <a:bodyPr wrap="square" lIns="0" tIns="0" rIns="0" bIns="0" rtlCol="0" anchor="ctr"/>
+          <a:lstStyle/>
+          <a:p>
+            <a:pPr algn="ctr" indent="0" marL="0">
+              <a:buNone/>
+            </a:pPr>
+            <a:r>
+              <a:rPr lang="en-US" sz="1200" i="1" dirty="0">
+                <a:solidFill>
+                  <a:srgbClr val="6366F1"/>
+                </a:solidFill>
+                <a:latin typeface="Calibri" pitchFamily="34" charset="0"/>
+                <a:ea typeface="Calibri" pitchFamily="34" charset="-122"/>
+                <a:cs typeface="Calibri" pitchFamily="34" charset="-120"/>
+              </a:rPr>
+              <a:t>All four sites share one CDP.  Watch the same customer recognized across every touchpoint — with personalized offers appearing in real time.</a:t>
+            </a:r>
+            <a:endParaRPr lang="en-US" sz="1200" dirty="0"/>
+          </a:p>
+        </p:txBody>
+      </p:sp>
+      <p:sp>
+        <p:nvSpPr>
+          <p:cNvPr id="32" name="Shape 30"/>
+          <p:cNvSpPr/>
+          <p:nvPr/>
+        </p:nvSpPr>
+        <p:spPr>
+          <a:xfrm>
+            <a:off x="0" y="4800600"/>
+            <a:ext cx="9144000" cy="342900"/>
+          </a:xfrm>
+          <a:prstGeom prst="rect">
+            <a:avLst/>
+          </a:prstGeom>
+          <a:solidFill>
+            <a:srgbClr val="1E293B"/>
+          </a:solidFill>
+          <a:ln w="12700">
+            <a:solidFill>
+              <a:srgbClr val="1E293B"/>
+            </a:solidFill>
+            <a:prstDash val="solid"/>
+          </a:ln>
+        </p:spPr>
+      </p:sp>
+      <p:sp>
+        <p:nvSpPr>
+          <p:cNvPr id="33" name="Text 31"/>
+          <p:cNvSpPr/>
+          <p:nvPr/>
+        </p:nvSpPr>
+        <p:spPr>
+          <a:xfrm>
+            <a:off x="228600" y="4828032"/>
+            <a:ext cx="274320" cy="256032"/>
+          </a:xfrm>
+          <a:prstGeom prst="rect">
+            <a:avLst/>
+          </a:prstGeom>
+          <a:noFill/>
+          <a:ln/>
+        </p:spPr>
+        <p:txBody>
+          <a:bodyPr wrap="square" lIns="0" tIns="0" rIns="0" bIns="0" rtlCol="0" anchor="ctr"/>
+          <a:lstStyle/>
+          <a:p>
+            <a:pPr indent="0" marL="0">
+              <a:buNone/>
+            </a:pPr>
+            <a:r>
+              <a:rPr lang="en-US" sz="1300" b="1" dirty="0">
+                <a:solidFill>
+                  <a:srgbClr val="6366F1"/>
+                </a:solidFill>
+                <a:latin typeface="Calibri" pitchFamily="34" charset="0"/>
+                <a:ea typeface="Calibri" pitchFamily="34" charset="-122"/>
+                <a:cs typeface="Calibri" pitchFamily="34" charset="-120"/>
+              </a:rPr>
+              <a:t>N</a:t>
+            </a:r>
+            <a:endParaRPr lang="en-US" sz="1300" dirty="0"/>
+          </a:p>
+        </p:txBody>
+      </p:sp>
+      <p:sp>
+        <p:nvSpPr>
+          <p:cNvPr id="34" name="Text 32"/>
+          <p:cNvSpPr/>
+          <p:nvPr/>
+        </p:nvSpPr>
+        <p:spPr>
+          <a:xfrm>
+            <a:off x="3200400" y="4828032"/>
+            <a:ext cx="2743200" cy="256032"/>
+          </a:xfrm>
+          <a:prstGeom prst="rect">
+            <a:avLst/>
+          </a:prstGeom>
+          <a:noFill/>
+          <a:ln/>
+        </p:spPr>
+        <p:txBody>
+          <a:bodyPr wrap="square" lIns="0" tIns="0" rIns="0" bIns="0" rtlCol="0" anchor="ctr"/>
+          <a:lstStyle/>
+          <a:p>
+            <a:pPr algn="ctr" indent="0" marL="0">
+              <a:buNone/>
+            </a:pPr>
+            <a:r>
+              <a:rPr lang="en-US" sz="900" b="1" spc="300" kern="0" dirty="0">
+                <a:solidFill>
+                  <a:srgbClr val="94A3B8"/>
+                </a:solidFill>
+                <a:latin typeface="Calibri" pitchFamily="34" charset="0"/>
+                <a:ea typeface="Calibri" pitchFamily="34" charset="-122"/>
+                <a:cs typeface="Calibri" pitchFamily="34" charset="-120"/>
+              </a:rPr>
+              <a:t>NEXUS CDP</a:t>
+            </a:r>
+            <a:endParaRPr lang="en-US" sz="900" dirty="0"/>
+          </a:p>
+        </p:txBody>
+      </p:sp>
+      <p:sp>
+        <p:nvSpPr>
+          <p:cNvPr id="35" name="Text 33"/>
+          <p:cNvSpPr/>
+          <p:nvPr/>
+        </p:nvSpPr>
+        <p:spPr>
+          <a:xfrm>
+            <a:off x="8686800" y="4828032"/>
+            <a:ext cx="320040" cy="256032"/>
+          </a:xfrm>
+          <a:prstGeom prst="rect">
+            <a:avLst/>
+          </a:prstGeom>
+          <a:noFill/>
+          <a:ln/>
+        </p:spPr>
+        <p:txBody>
+          <a:bodyPr wrap="square" lIns="0" tIns="0" rIns="0" bIns="0" rtlCol="0" anchor="ctr"/>
+          <a:lstStyle/>
+          <a:p>
+            <a:pPr algn="r" indent="0" marL="0">
+              <a:buNone/>
+            </a:pPr>
+            <a:r>
+              <a:rPr lang="en-US" sz="1000" dirty="0">
+                <a:solidFill>
+                  <a:srgbClr val="94A3B8"/>
+                </a:solidFill>
+                <a:latin typeface="Calibri" pitchFamily="34" charset="0"/>
+                <a:ea typeface="Calibri" pitchFamily="34" charset="-122"/>
+                <a:cs typeface="Calibri" pitchFamily="34" charset="-120"/>
+              </a:rPr>
+              <a:t>10</a:t>
+            </a:r>
+            <a:endParaRPr lang="en-US" sz="1000" dirty="0"/>
+          </a:p>
+        </p:txBody>
+      </p:sp>
+    </p:spTree>
+  </p:cSld>
+  <p:clrMapOvr>
+    <a:masterClrMapping/>
+  </p:clrMapOvr>
+</p:sld>
+</file>
+
+<file path=ppt/slides/slide11.xml><?xml version="1.0" encoding="utf-8"?>
+<p:sld xmlns:a="http://schemas.openxmlformats.org/drawingml/2006/main" xmlns:r="http://schemas.openxmlformats.org/officeDocument/2006/relationships" xmlns:p="http://schemas.openxmlformats.org/presentationml/2006/main">
+  <p:cSld name="Slide 11">
+    <p:bg>
+      <p:bgPr>
+        <a:solidFill>
           <a:srgbClr val="0F172A"/>
         </a:solidFill>
       </p:bgPr>
@@ -3284,7 +4577,7 @@
                 <a:ea typeface="Calibri" pitchFamily="34" charset="-122"/>
                 <a:cs typeface="Calibri" pitchFamily="34" charset="-120"/>
               </a:rPr>
-              <a:t>10</a:t>
+              <a:t>11</a:t>
             </a:r>
             <a:endParaRPr lang="en-US" sz="1000" dirty="0"/>
           </a:p>
@@ -3298,9 +4591,9 @@
 </p:sld>
 </file>
 
-<file path=ppt/slides/slide11.xml><?xml version="1.0" encoding="utf-8"?>
+<file path=ppt/slides/slide12.xml><?xml version="1.0" encoding="utf-8"?>
 <p:sld xmlns:a="http://schemas.openxmlformats.org/drawingml/2006/main" xmlns:r="http://schemas.openxmlformats.org/officeDocument/2006/relationships" xmlns:p="http://schemas.openxmlformats.org/presentationml/2006/main">
-  <p:cSld name="Slide 11">
+  <p:cSld name="Slide 12">
     <p:bg>
       <p:bgPr>
         <a:solidFill>
@@ -4010,7 +5303,7 @@
                 <a:ea typeface="Calibri" pitchFamily="34" charset="-122"/>
                 <a:cs typeface="Calibri" pitchFamily="34" charset="-120"/>
               </a:rPr>
-              <a:t>11</a:t>
+              <a:t>12</a:t>
             </a:r>
             <a:endParaRPr lang="en-US" sz="1000" dirty="0"/>
           </a:p>
@@ -4024,9 +5317,9 @@
 </p:sld>
 </file>
 
-<file path=ppt/slides/slide12.xml><?xml version="1.0" encoding="utf-8"?>
+<file path=ppt/slides/slide13.xml><?xml version="1.0" encoding="utf-8"?>
 <p:sld xmlns:a="http://schemas.openxmlformats.org/drawingml/2006/main" xmlns:r="http://schemas.openxmlformats.org/officeDocument/2006/relationships" xmlns:p="http://schemas.openxmlformats.org/presentationml/2006/main">
-  <p:cSld name="Slide 12">
+  <p:cSld name="Slide 13">
     <p:bg>
       <p:bgPr>
         <a:solidFill>
@@ -4918,7 +6211,7 @@
                 <a:ea typeface="Calibri" pitchFamily="34" charset="-122"/>
                 <a:cs typeface="Calibri" pitchFamily="34" charset="-120"/>
               </a:rPr>
-              <a:t>12</a:t>
+              <a:t>13</a:t>
             </a:r>
             <a:endParaRPr lang="en-US" sz="1000" dirty="0"/>
           </a:p>
@@ -11349,7 +12642,7 @@
                 <a:ea typeface="Calibri" pitchFamily="34" charset="-122"/>
                 <a:cs typeface="Calibri" pitchFamily="34" charset="-120"/>
               </a:rPr>
-              <a:t>Opportunity</a:t>
+              <a:t>Offer Unlocked</a:t>
             </a:r>
             <a:endParaRPr lang="en-US" sz="1100" dirty="0"/>
           </a:p>
@@ -11541,7 +12834,7 @@
                 <a:ea typeface="Calibri" pitchFamily="34" charset="-122"/>
                 <a:cs typeface="Calibri" pitchFamily="34" charset="-120"/>
               </a:rPr>
-              <a:t>Outreach from a sales advisor</a:t>
+              <a:t>5% member discount — gold price on storefront + offer card</a:t>
             </a:r>
             <a:endParaRPr lang="en-US" sz="1000" dirty="0"/>
           </a:p>
@@ -11733,7 +13026,7 @@
                 <a:ea typeface="Calibri" pitchFamily="34" charset="-122"/>
                 <a:cs typeface="Calibri" pitchFamily="34" charset="-120"/>
               </a:rPr>
-              <a:t>Personalized nudge to earn more</a:t>
+              <a:t>Double Points Weekend — book service for 2× points</a:t>
             </a:r>
             <a:endParaRPr lang="en-US" sz="1000" dirty="0"/>
           </a:p>
@@ -11925,7 +13218,7 @@
                 <a:ea typeface="Calibri" pitchFamily="34" charset="-122"/>
                 <a:cs typeface="Calibri" pitchFamily="34" charset="-120"/>
               </a:rPr>
-              <a:t>In-drive safety or convenience offer</a:t>
+              <a:t>3× rental points + 500 bonus service points (2 cards)</a:t>
             </a:r>
             <a:endParaRPr lang="en-US" sz="1000" dirty="0"/>
           </a:p>
@@ -12117,7 +13410,7 @@
                 <a:ea typeface="Calibri" pitchFamily="34" charset="-122"/>
                 <a:cs typeface="Calibri" pitchFamily="34" charset="-120"/>
               </a:rPr>
-              <a:t>Trade-in or purchase conversation</a:t>
+              <a:t>$500 trade-in credit toward any new Apex vehicle</a:t>
             </a:r>
             <a:endParaRPr lang="en-US" sz="1000" dirty="0"/>
           </a:p>
@@ -12309,7 +13602,7 @@
                 <a:ea typeface="Calibri" pitchFamily="34" charset="-122"/>
                 <a:cs typeface="Calibri" pitchFamily="34" charset="-120"/>
               </a:rPr>
-              <a:t>Activate in-store associate alert</a:t>
+              <a:t>Free appraisal + $250 accessories credit (today only)</a:t>
             </a:r>
             <a:endParaRPr lang="en-US" sz="1000" dirty="0"/>
           </a:p>
@@ -12501,7 +13794,7 @@
                 <a:ea typeface="Calibri" pitchFamily="34" charset="-122"/>
                 <a:cs typeface="Calibri" pitchFamily="34" charset="-120"/>
               </a:rPr>
-              <a:t>Win-back campaign trigger</a:t>
+              <a:t>Welcome Back — 1,000 bonus loyalty points</a:t>
             </a:r>
             <a:endParaRPr lang="en-US" sz="1000" dirty="0"/>
           </a:p>
@@ -12540,7 +13833,7 @@
                 <a:ea typeface="Calibri" pitchFamily="34" charset="-122"/>
                 <a:cs typeface="Calibri" pitchFamily="34" charset="-120"/>
               </a:rPr>
-              <a:t>Signals are defined by your team, for your moments.</a:t>
+              <a:t>Every signal automatically creates a personalized offer — in the loyalty portal and on the storefront.</a:t>
             </a:r>
             <a:endParaRPr lang="en-US" sz="1150" dirty="0"/>
           </a:p>
@@ -13387,7 +14680,7 @@
                 <a:ea typeface="Calibri" pitchFamily="34" charset="-122"/>
                 <a:cs typeface="Calibri" pitchFamily="34" charset="-120"/>
               </a:rPr>
-              <a:t>Who can subscribe?  CRM systems · Marketing platforms · In-store associate apps · Mobile push services · Data warehouses — anything with an HTTP endpoint.</a:t>
+              <a:t>Built-in: the Offer Engine subscribes to all 6 signals automatically — delivering personalized offers in real time to the loyalty portal and storefront. Any external system can subscribe too: CRM, push notifications, data warehouses, in-store apps.</a:t>
             </a:r>
             <a:endParaRPr lang="en-US" sz="1200" dirty="0"/>
           </a:p>
@@ -13592,7 +14885,7 @@
               <a:buNone/>
             </a:pPr>
             <a:r>
-              <a:rPr lang="en-US" sz="2600" b="1" dirty="0">
+              <a:rPr lang="en-US" sz="2400" b="1" dirty="0">
                 <a:solidFill>
                   <a:srgbClr val="0F172A"/>
                 </a:solidFill>
@@ -13600,22 +14893,61 @@
                 <a:ea typeface="Calibri" pitchFamily="34" charset="-122"/>
                 <a:cs typeface="Calibri" pitchFamily="34" charset="-120"/>
               </a:rPr>
-              <a:t>See It Live: The Apex Motors Story</a:t>
-            </a:r>
-            <a:endParaRPr lang="en-US" sz="2600" dirty="0"/>
-          </a:p>
-        </p:txBody>
-      </p:sp>
-      <p:sp>
-        <p:nvSpPr>
-          <p:cNvPr id="3" name="Shape 1"/>
-          <p:cNvSpPr/>
-          <p:nvPr/>
-        </p:nvSpPr>
-        <p:spPr>
-          <a:xfrm>
-            <a:off x="365760" y="1005840"/>
-            <a:ext cx="4114800" cy="1600200"/>
+              <a:t>From Signal to Personalized Offer — Automatically</a:t>
+            </a:r>
+            <a:endParaRPr lang="en-US" sz="2400" dirty="0"/>
+          </a:p>
+        </p:txBody>
+      </p:sp>
+      <p:sp>
+        <p:nvSpPr>
+          <p:cNvPr id="3" name="Text 1"/>
+          <p:cNvSpPr/>
+          <p:nvPr/>
+        </p:nvSpPr>
+        <p:spPr>
+          <a:xfrm>
+            <a:off x="457200" y="749808"/>
+            <a:ext cx="8229600" cy="347472"/>
+          </a:xfrm>
+          <a:prstGeom prst="rect">
+            <a:avLst/>
+          </a:prstGeom>
+          <a:noFill/>
+          <a:ln/>
+        </p:spPr>
+        <p:txBody>
+          <a:bodyPr wrap="square" lIns="0" tIns="0" rIns="0" bIns="0" rtlCol="0" anchor="ctr"/>
+          <a:lstStyle/>
+          <a:p>
+            <a:pPr indent="0" marL="0">
+              <a:buNone/>
+            </a:pPr>
+            <a:r>
+              <a:rPr lang="en-US" sz="1200" i="1" dirty="0">
+                <a:solidFill>
+                  <a:srgbClr val="94A3B8"/>
+                </a:solidFill>
+                <a:latin typeface="Calibri" pitchFamily="34" charset="0"/>
+                <a:ea typeface="Calibri" pitchFamily="34" charset="-122"/>
+                <a:cs typeface="Calibri" pitchFamily="34" charset="-120"/>
+              </a:rPr>
+              <a:t>Every signal firing creates a contextual offer in real time — visible in the loyalty portal and, where relevant, directly on the storefront.</a:t>
+            </a:r>
+            <a:endParaRPr lang="en-US" sz="1200" dirty="0"/>
+          </a:p>
+        </p:txBody>
+      </p:sp>
+      <p:sp>
+        <p:nvSpPr>
+          <p:cNvPr id="4" name="Shape 2"/>
+          <p:cNvSpPr/>
+          <p:nvPr/>
+        </p:nvSpPr>
+        <p:spPr>
+          <a:xfrm>
+            <a:off x="365760" y="1188720"/>
+            <a:ext cx="3931920" cy="960120"/>
           </a:xfrm>
           <a:prstGeom prst="rect">
             <a:avLst/>
@@ -13640,14 +14972,14 @@
       </p:sp>
       <p:sp>
         <p:nvSpPr>
-          <p:cNvPr id="4" name="Shape 2"/>
-          <p:cNvSpPr/>
-          <p:nvPr/>
-        </p:nvSpPr>
-        <p:spPr>
-          <a:xfrm>
-            <a:off x="365760" y="1005840"/>
-            <a:ext cx="4114800" cy="91440"/>
+          <p:cNvPr id="5" name="Shape 3"/>
+          <p:cNvSpPr/>
+          <p:nvPr/>
+        </p:nvSpPr>
+        <p:spPr>
+          <a:xfrm>
+            <a:off x="365760" y="1188720"/>
+            <a:ext cx="3931920" cy="82296"/>
           </a:xfrm>
           <a:prstGeom prst="rect">
             <a:avLst/>
@@ -13665,65 +14997,40 @@
       </p:sp>
       <p:sp>
         <p:nvSpPr>
-          <p:cNvPr id="5" name="Shape 3"/>
-          <p:cNvSpPr/>
-          <p:nvPr/>
-        </p:nvSpPr>
-        <p:spPr>
-          <a:xfrm>
-            <a:off x="502920" y="1188720"/>
-            <a:ext cx="384048" cy="384048"/>
-          </a:xfrm>
-          <a:prstGeom prst="ellipse">
-            <a:avLst/>
-          </a:prstGeom>
-          <a:solidFill>
-            <a:srgbClr val="6366F1"/>
-          </a:solidFill>
-          <a:ln w="12700">
-            <a:solidFill>
-              <a:srgbClr val="6366F1"/>
-            </a:solidFill>
-            <a:prstDash val="solid"/>
-          </a:ln>
-        </p:spPr>
-      </p:sp>
-      <p:sp>
-        <p:nvSpPr>
           <p:cNvPr id="6" name="Text 4"/>
           <p:cNvSpPr/>
           <p:nvPr/>
         </p:nvSpPr>
         <p:spPr>
           <a:xfrm>
-            <a:off x="502920" y="1188720"/>
-            <a:ext cx="384048" cy="384048"/>
-          </a:xfrm>
-          <a:prstGeom prst="rect">
-            <a:avLst/>
-          </a:prstGeom>
-          <a:noFill/>
-          <a:ln/>
-        </p:spPr>
-        <p:txBody>
-          <a:bodyPr wrap="square" lIns="0" tIns="0" rIns="0" bIns="0" rtlCol="0" anchor="ctr"/>
-          <a:lstStyle/>
-          <a:p>
-            <a:pPr algn="ctr" indent="0" marL="0">
-              <a:buNone/>
-            </a:pPr>
-            <a:r>
-              <a:rPr lang="en-US" sz="750" b="1" dirty="0">
-                <a:solidFill>
-                  <a:srgbClr val="FFFFFF"/>
-                </a:solidFill>
-                <a:latin typeface="Calibri" pitchFamily="34" charset="0"/>
-                <a:ea typeface="Calibri" pitchFamily="34" charset="-122"/>
-                <a:cs typeface="Calibri" pitchFamily="34" charset="-120"/>
-              </a:rPr>
-              <a:t>Site A</a:t>
-            </a:r>
-            <a:endParaRPr lang="en-US" sz="750" dirty="0"/>
+            <a:off x="548640" y="1298448"/>
+            <a:ext cx="3657600" cy="320040"/>
+          </a:xfrm>
+          <a:prstGeom prst="rect">
+            <a:avLst/>
+          </a:prstGeom>
+          <a:noFill/>
+          <a:ln/>
+        </p:spPr>
+        <p:txBody>
+          <a:bodyPr wrap="square" lIns="0" tIns="0" rIns="0" bIns="0" rtlCol="0" anchor="ctr"/>
+          <a:lstStyle/>
+          <a:p>
+            <a:pPr indent="0" marL="0">
+              <a:buNone/>
+            </a:pPr>
+            <a:r>
+              <a:rPr lang="en-US" sz="1200" b="1" dirty="0">
+                <a:solidFill>
+                  <a:srgbClr val="0F172A"/>
+                </a:solidFill>
+                <a:latin typeface="Calibri" pitchFamily="34" charset="0"/>
+                <a:ea typeface="Calibri" pitchFamily="34" charset="-122"/>
+                <a:cs typeface="Calibri" pitchFamily="34" charset="-120"/>
+              </a:rPr>
+              <a:t>Push  ·  Webhook delivers offer on every signal firing</a:t>
+            </a:r>
+            <a:endParaRPr lang="en-US" sz="1200" dirty="0"/>
           </a:p>
         </p:txBody>
       </p:sp>
@@ -13735,8 +15042,8 @@
         </p:nvSpPr>
         <p:spPr>
           <a:xfrm>
-            <a:off x="960120" y="1188720"/>
-            <a:ext cx="3383280" cy="384048"/>
+            <a:off x="548640" y="1618488"/>
+            <a:ext cx="3657600" cy="438912"/>
           </a:xfrm>
           <a:prstGeom prst="rect">
             <a:avLst/>
@@ -13752,85 +15059,7 @@
               <a:buNone/>
             </a:pPr>
             <a:r>
-              <a:rPr lang="en-US" sz="1300" b="1" dirty="0">
-                <a:solidFill>
-                  <a:srgbClr val="0F172A"/>
-                </a:solidFill>
-                <a:latin typeface="Calibri" pitchFamily="34" charset="0"/>
-                <a:ea typeface="Calibri" pitchFamily="34" charset="-122"/>
-                <a:cs typeface="Calibri" pitchFamily="34" charset="-120"/>
-              </a:rPr>
-              <a:t>🏎️  Apex Motors Storefront</a:t>
-            </a:r>
-            <a:endParaRPr lang="en-US" sz="1300" dirty="0"/>
-          </a:p>
-        </p:txBody>
-      </p:sp>
-      <p:sp>
-        <p:nvSpPr>
-          <p:cNvPr id="8" name="Text 6"/>
-          <p:cNvSpPr/>
-          <p:nvPr/>
-        </p:nvSpPr>
-        <p:spPr>
-          <a:xfrm>
-            <a:off x="960120" y="1572768"/>
-            <a:ext cx="3383280" cy="256032"/>
-          </a:xfrm>
-          <a:prstGeom prst="rect">
-            <a:avLst/>
-          </a:prstGeom>
-          <a:noFill/>
-          <a:ln/>
-        </p:spPr>
-        <p:txBody>
-          <a:bodyPr wrap="square" lIns="0" tIns="0" rIns="0" bIns="0" rtlCol="0" anchor="ctr"/>
-          <a:lstStyle/>
-          <a:p>
-            <a:pPr indent="0" marL="0">
-              <a:buNone/>
-            </a:pPr>
-            <a:r>
-              <a:rPr lang="en-US" sz="950" dirty="0">
-                <a:solidFill>
-                  <a:srgbClr val="6366F1"/>
-                </a:solidFill>
-                <a:latin typeface="Consolas" pitchFamily="34" charset="0"/>
-                <a:ea typeface="Consolas" pitchFamily="34" charset="-122"/>
-                <a:cs typeface="Consolas" pitchFamily="34" charset="-120"/>
-              </a:rPr>
-              <a:t>localhost:3001</a:t>
-            </a:r>
-            <a:endParaRPr lang="en-US" sz="950" dirty="0"/>
-          </a:p>
-        </p:txBody>
-      </p:sp>
-      <p:sp>
-        <p:nvSpPr>
-          <p:cNvPr id="9" name="Text 7"/>
-          <p:cNvSpPr/>
-          <p:nvPr/>
-        </p:nvSpPr>
-        <p:spPr>
-          <a:xfrm>
-            <a:off x="502920" y="1874520"/>
-            <a:ext cx="3840480" cy="594360"/>
-          </a:xfrm>
-          <a:prstGeom prst="rect">
-            <a:avLst/>
-          </a:prstGeom>
-          <a:noFill/>
-          <a:ln/>
-        </p:spPr>
-        <p:txBody>
-          <a:bodyPr wrap="square" lIns="0" tIns="0" rIns="0" bIns="0" rtlCol="0" anchor="ctr"/>
-          <a:lstStyle/>
-          <a:p>
-            <a:pPr indent="0" marL="0">
-              <a:buNone/>
-            </a:pPr>
-            <a:r>
-              <a:rPr lang="en-US" sz="1050" dirty="0">
+              <a:rPr lang="en-US" sz="1000" dirty="0">
                 <a:solidFill>
                   <a:srgbClr val="475569"/>
                 </a:solidFill>
@@ -13838,260 +15067,22 @@
                 <a:ea typeface="Calibri" pitchFamily="34" charset="-122"/>
                 <a:cs typeface="Calibri" pitchFamily="34" charset="-120"/>
               </a:rPr>
-              <a:t>Browse vehicles, schedule service, track purchase intent signals in real time</a:t>
-            </a:r>
-            <a:endParaRPr lang="en-US" sz="1050" dirty="0"/>
-          </a:p>
-        </p:txBody>
-      </p:sp>
-      <p:sp>
-        <p:nvSpPr>
-          <p:cNvPr id="10" name="Shape 8"/>
-          <p:cNvSpPr/>
-          <p:nvPr/>
-        </p:nvSpPr>
-        <p:spPr>
-          <a:xfrm>
-            <a:off x="4663440" y="1005840"/>
-            <a:ext cx="4114800" cy="1600200"/>
-          </a:xfrm>
-          <a:prstGeom prst="rect">
-            <a:avLst/>
-          </a:prstGeom>
-          <a:solidFill>
-            <a:srgbClr val="FFFFFF"/>
-          </a:solidFill>
-          <a:ln w="19050">
-            <a:solidFill>
-              <a:srgbClr val="F59E0B"/>
-            </a:solidFill>
-            <a:prstDash val="solid"/>
-          </a:ln>
-          <a:effectLst>
-            <a:outerShdw sx="100000" sy="100000" kx="0" ky="0" algn="bl" rotWithShape="0" blurRad="101600" dist="38100" dir="8100000">
-              <a:srgbClr val="000000">
-                <a:alpha val="25000"/>
-              </a:srgbClr>
-            </a:outerShdw>
-          </a:effectLst>
-        </p:spPr>
-      </p:sp>
-      <p:sp>
-        <p:nvSpPr>
-          <p:cNvPr id="11" name="Shape 9"/>
-          <p:cNvSpPr/>
-          <p:nvPr/>
-        </p:nvSpPr>
-        <p:spPr>
-          <a:xfrm>
-            <a:off x="4663440" y="1005840"/>
-            <a:ext cx="4114800" cy="91440"/>
-          </a:xfrm>
-          <a:prstGeom prst="rect">
-            <a:avLst/>
-          </a:prstGeom>
-          <a:solidFill>
-            <a:srgbClr val="F59E0B"/>
-          </a:solidFill>
-          <a:ln w="12700">
-            <a:solidFill>
-              <a:srgbClr val="F59E0B"/>
-            </a:solidFill>
-            <a:prstDash val="solid"/>
-          </a:ln>
-        </p:spPr>
-      </p:sp>
-      <p:sp>
-        <p:nvSpPr>
-          <p:cNvPr id="12" name="Shape 10"/>
-          <p:cNvSpPr/>
-          <p:nvPr/>
-        </p:nvSpPr>
-        <p:spPr>
-          <a:xfrm>
-            <a:off x="4800600" y="1188720"/>
-            <a:ext cx="384048" cy="384048"/>
-          </a:xfrm>
-          <a:prstGeom prst="ellipse">
-            <a:avLst/>
-          </a:prstGeom>
-          <a:solidFill>
-            <a:srgbClr val="F59E0B"/>
-          </a:solidFill>
-          <a:ln w="12700">
-            <a:solidFill>
-              <a:srgbClr val="F59E0B"/>
-            </a:solidFill>
-            <a:prstDash val="solid"/>
-          </a:ln>
-        </p:spPr>
-      </p:sp>
-      <p:sp>
-        <p:nvSpPr>
-          <p:cNvPr id="13" name="Text 11"/>
-          <p:cNvSpPr/>
-          <p:nvPr/>
-        </p:nvSpPr>
-        <p:spPr>
-          <a:xfrm>
-            <a:off x="4800600" y="1188720"/>
-            <a:ext cx="384048" cy="384048"/>
-          </a:xfrm>
-          <a:prstGeom prst="rect">
-            <a:avLst/>
-          </a:prstGeom>
-          <a:noFill/>
-          <a:ln/>
-        </p:spPr>
-        <p:txBody>
-          <a:bodyPr wrap="square" lIns="0" tIns="0" rIns="0" bIns="0" rtlCol="0" anchor="ctr"/>
-          <a:lstStyle/>
-          <a:p>
-            <a:pPr algn="ctr" indent="0" marL="0">
-              <a:buNone/>
-            </a:pPr>
-            <a:r>
-              <a:rPr lang="en-US" sz="750" b="1" dirty="0">
-                <a:solidFill>
-                  <a:srgbClr val="FFFFFF"/>
-                </a:solidFill>
-                <a:latin typeface="Calibri" pitchFamily="34" charset="0"/>
-                <a:ea typeface="Calibri" pitchFamily="34" charset="-122"/>
-                <a:cs typeface="Calibri" pitchFamily="34" charset="-120"/>
-              </a:rPr>
-              <a:t>Site B</a:t>
-            </a:r>
-            <a:endParaRPr lang="en-US" sz="750" dirty="0"/>
-          </a:p>
-        </p:txBody>
-      </p:sp>
-      <p:sp>
-        <p:nvSpPr>
-          <p:cNvPr id="14" name="Text 12"/>
-          <p:cNvSpPr/>
-          <p:nvPr/>
-        </p:nvSpPr>
-        <p:spPr>
-          <a:xfrm>
-            <a:off x="5257800" y="1188720"/>
-            <a:ext cx="3383280" cy="384048"/>
-          </a:xfrm>
-          <a:prstGeom prst="rect">
-            <a:avLst/>
-          </a:prstGeom>
-          <a:noFill/>
-          <a:ln/>
-        </p:spPr>
-        <p:txBody>
-          <a:bodyPr wrap="square" lIns="0" tIns="0" rIns="0" bIns="0" rtlCol="0" anchor="ctr"/>
-          <a:lstStyle/>
-          <a:p>
-            <a:pPr indent="0" marL="0">
-              <a:buNone/>
-            </a:pPr>
-            <a:r>
-              <a:rPr lang="en-US" sz="1300" b="1" dirty="0">
-                <a:solidFill>
-                  <a:srgbClr val="0F172A"/>
-                </a:solidFill>
-                <a:latin typeface="Calibri" pitchFamily="34" charset="0"/>
-                <a:ea typeface="Calibri" pitchFamily="34" charset="-122"/>
-                <a:cs typeface="Calibri" pitchFamily="34" charset="-120"/>
-              </a:rPr>
-              <a:t>⭐  Apex Rewards Portal</a:t>
-            </a:r>
-            <a:endParaRPr lang="en-US" sz="1300" dirty="0"/>
-          </a:p>
-        </p:txBody>
-      </p:sp>
-      <p:sp>
-        <p:nvSpPr>
-          <p:cNvPr id="15" name="Text 13"/>
-          <p:cNvSpPr/>
-          <p:nvPr/>
-        </p:nvSpPr>
-        <p:spPr>
-          <a:xfrm>
-            <a:off x="5257800" y="1572768"/>
-            <a:ext cx="3383280" cy="256032"/>
-          </a:xfrm>
-          <a:prstGeom prst="rect">
-            <a:avLst/>
-          </a:prstGeom>
-          <a:noFill/>
-          <a:ln/>
-        </p:spPr>
-        <p:txBody>
-          <a:bodyPr wrap="square" lIns="0" tIns="0" rIns="0" bIns="0" rtlCol="0" anchor="ctr"/>
-          <a:lstStyle/>
-          <a:p>
-            <a:pPr indent="0" marL="0">
-              <a:buNone/>
-            </a:pPr>
-            <a:r>
-              <a:rPr lang="en-US" sz="950" dirty="0">
-                <a:solidFill>
-                  <a:srgbClr val="F59E0B"/>
-                </a:solidFill>
-                <a:latin typeface="Consolas" pitchFamily="34" charset="0"/>
-                <a:ea typeface="Consolas" pitchFamily="34" charset="-122"/>
-                <a:cs typeface="Consolas" pitchFamily="34" charset="-120"/>
-              </a:rPr>
-              <a:t>localhost:3002</a:t>
-            </a:r>
-            <a:endParaRPr lang="en-US" sz="950" dirty="0"/>
-          </a:p>
-        </p:txBody>
-      </p:sp>
-      <p:sp>
-        <p:nvSpPr>
-          <p:cNvPr id="16" name="Text 14"/>
-          <p:cNvSpPr/>
-          <p:nvPr/>
-        </p:nvSpPr>
-        <p:spPr>
-          <a:xfrm>
-            <a:off x="4800600" y="1874520"/>
-            <a:ext cx="3840480" cy="594360"/>
-          </a:xfrm>
-          <a:prstGeom prst="rect">
-            <a:avLst/>
-          </a:prstGeom>
-          <a:noFill/>
-          <a:ln/>
-        </p:spPr>
-        <p:txBody>
-          <a:bodyPr wrap="square" lIns="0" tIns="0" rIns="0" bIns="0" rtlCol="0" anchor="ctr"/>
-          <a:lstStyle/>
-          <a:p>
-            <a:pPr indent="0" marL="0">
-              <a:buNone/>
-            </a:pPr>
-            <a:r>
-              <a:rPr lang="en-US" sz="1050" dirty="0">
-                <a:solidFill>
-                  <a:srgbClr val="475569"/>
-                </a:solidFill>
-                <a:latin typeface="Calibri" pitchFamily="34" charset="0"/>
-                <a:ea typeface="Calibri" pitchFamily="34" charset="-122"/>
-                <a:cs typeface="Calibri" pitchFamily="34" charset="-120"/>
-              </a:rPr>
-              <a:t>Loyalty dashboard with live cross-domain identity merge demonstration</a:t>
-            </a:r>
-            <a:endParaRPr lang="en-US" sz="1050" dirty="0"/>
-          </a:p>
-        </p:txBody>
-      </p:sp>
-      <p:sp>
-        <p:nvSpPr>
-          <p:cNvPr id="17" name="Shape 15"/>
-          <p:cNvSpPr/>
-          <p:nvPr/>
-        </p:nvSpPr>
-        <p:spPr>
-          <a:xfrm>
-            <a:off x="365760" y="2788920"/>
-            <a:ext cx="4114800" cy="1600200"/>
+              <a:t>All 6 signals auto-subscribed via WEBHOOK_OFFERS_URL on every deploy. Delivery log visible in CDP Platform.</a:t>
+            </a:r>
+            <a:endParaRPr lang="en-US" sz="1000" dirty="0"/>
+          </a:p>
+        </p:txBody>
+      </p:sp>
+      <p:sp>
+        <p:nvSpPr>
+          <p:cNvPr id="8" name="Shape 6"/>
+          <p:cNvSpPr/>
+          <p:nvPr/>
+        </p:nvSpPr>
+        <p:spPr>
+          <a:xfrm>
+            <a:off x="4754880" y="1188720"/>
+            <a:ext cx="4023360" cy="960120"/>
           </a:xfrm>
           <a:prstGeom prst="rect">
             <a:avLst/>
@@ -14116,14 +15107,14 @@
       </p:sp>
       <p:sp>
         <p:nvSpPr>
-          <p:cNvPr id="18" name="Shape 16"/>
-          <p:cNvSpPr/>
-          <p:nvPr/>
-        </p:nvSpPr>
-        <p:spPr>
-          <a:xfrm>
-            <a:off x="365760" y="2788920"/>
-            <a:ext cx="4114800" cy="91440"/>
+          <p:cNvPr id="9" name="Shape 7"/>
+          <p:cNvSpPr/>
+          <p:nvPr/>
+        </p:nvSpPr>
+        <p:spPr>
+          <a:xfrm>
+            <a:off x="4754880" y="1188720"/>
+            <a:ext cx="4023360" cy="82296"/>
           </a:xfrm>
           <a:prstGeom prst="rect">
             <a:avLst/>
@@ -14141,24 +15132,102 @@
       </p:sp>
       <p:sp>
         <p:nvSpPr>
-          <p:cNvPr id="19" name="Shape 17"/>
-          <p:cNvSpPr/>
-          <p:nvPr/>
-        </p:nvSpPr>
-        <p:spPr>
-          <a:xfrm>
-            <a:off x="502920" y="2971800"/>
-            <a:ext cx="384048" cy="384048"/>
-          </a:xfrm>
-          <a:prstGeom prst="ellipse">
-            <a:avLst/>
-          </a:prstGeom>
-          <a:solidFill>
-            <a:srgbClr val="10B981"/>
+          <p:cNvPr id="10" name="Text 8"/>
+          <p:cNvSpPr/>
+          <p:nvPr/>
+        </p:nvSpPr>
+        <p:spPr>
+          <a:xfrm>
+            <a:off x="4937760" y="1298448"/>
+            <a:ext cx="3749040" cy="320040"/>
+          </a:xfrm>
+          <a:prstGeom prst="rect">
+            <a:avLst/>
+          </a:prstGeom>
+          <a:noFill/>
+          <a:ln/>
+        </p:spPr>
+        <p:txBody>
+          <a:bodyPr wrap="square" lIns="0" tIns="0" rIns="0" bIns="0" rtlCol="0" anchor="ctr"/>
+          <a:lstStyle/>
+          <a:p>
+            <a:pPr indent="0" marL="0">
+              <a:buNone/>
+            </a:pPr>
+            <a:r>
+              <a:rPr lang="en-US" sz="1200" b="1" dirty="0">
+                <a:solidFill>
+                  <a:srgbClr val="0F172A"/>
+                </a:solidFill>
+                <a:latin typeface="Calibri" pitchFamily="34" charset="0"/>
+                <a:ea typeface="Calibri" pitchFamily="34" charset="-122"/>
+                <a:cs typeface="Calibri" pitchFamily="34" charset="-120"/>
+              </a:rPr>
+              <a:t>Pull  ·  Sync on every portal poll (every 5s)</a:t>
+            </a:r>
+            <a:endParaRPr lang="en-US" sz="1200" dirty="0"/>
+          </a:p>
+        </p:txBody>
+      </p:sp>
+      <p:sp>
+        <p:nvSpPr>
+          <p:cNvPr id="11" name="Text 9"/>
+          <p:cNvSpPr/>
+          <p:nvPr/>
+        </p:nvSpPr>
+        <p:spPr>
+          <a:xfrm>
+            <a:off x="4937760" y="1618488"/>
+            <a:ext cx="3749040" cy="438912"/>
+          </a:xfrm>
+          <a:prstGeom prst="rect">
+            <a:avLst/>
+          </a:prstGeom>
+          <a:noFill/>
+          <a:ln/>
+        </p:spPr>
+        <p:txBody>
+          <a:bodyPr wrap="square" lIns="0" tIns="0" rIns="0" bIns="0" rtlCol="0" anchor="ctr"/>
+          <a:lstStyle/>
+          <a:p>
+            <a:pPr indent="0" marL="0">
+              <a:buNone/>
+            </a:pPr>
+            <a:r>
+              <a:rPr lang="en-US" sz="1000" dirty="0">
+                <a:solidFill>
+                  <a:srgbClr val="475569"/>
+                </a:solidFill>
+                <a:latin typeface="Calibri" pitchFamily="34" charset="0"/>
+                <a:ea typeface="Calibri" pitchFamily="34" charset="-122"/>
+                <a:cs typeface="Calibri" pitchFamily="34" charset="-120"/>
+              </a:rPr>
+              <a:t>Portal checks active signal firings on each refresh — self-heals any missed webhooks automatically.</a:t>
+            </a:r>
+            <a:endParaRPr lang="en-US" sz="1000" dirty="0"/>
+          </a:p>
+        </p:txBody>
+      </p:sp>
+      <p:sp>
+        <p:nvSpPr>
+          <p:cNvPr id="12" name="Shape 10"/>
+          <p:cNvSpPr/>
+          <p:nvPr/>
+        </p:nvSpPr>
+        <p:spPr>
+          <a:xfrm>
+            <a:off x="365760" y="2331720"/>
+            <a:ext cx="2377440" cy="292608"/>
+          </a:xfrm>
+          <a:prstGeom prst="rect">
+            <a:avLst/>
+          </a:prstGeom>
+          <a:solidFill>
+            <a:srgbClr val="0F172A"/>
           </a:solidFill>
           <a:ln w="12700">
             <a:solidFill>
-              <a:srgbClr val="10B981"/>
+              <a:srgbClr val="0F172A"/>
             </a:solidFill>
             <a:prstDash val="solid"/>
           </a:ln>
@@ -14166,30 +15235,30 @@
       </p:sp>
       <p:sp>
         <p:nvSpPr>
-          <p:cNvPr id="20" name="Text 18"/>
-          <p:cNvSpPr/>
-          <p:nvPr/>
-        </p:nvSpPr>
-        <p:spPr>
-          <a:xfrm>
-            <a:off x="502920" y="2971800"/>
-            <a:ext cx="384048" cy="384048"/>
-          </a:xfrm>
-          <a:prstGeom prst="rect">
-            <a:avLst/>
-          </a:prstGeom>
-          <a:noFill/>
-          <a:ln/>
-        </p:spPr>
-        <p:txBody>
-          <a:bodyPr wrap="square" lIns="0" tIns="0" rIns="0" bIns="0" rtlCol="0" anchor="ctr"/>
-          <a:lstStyle/>
-          <a:p>
-            <a:pPr algn="ctr" indent="0" marL="0">
-              <a:buNone/>
-            </a:pPr>
-            <a:r>
-              <a:rPr lang="en-US" sz="750" b="1" dirty="0">
+          <p:cNvPr id="13" name="Text 11"/>
+          <p:cNvSpPr/>
+          <p:nvPr/>
+        </p:nvSpPr>
+        <p:spPr>
+          <a:xfrm>
+            <a:off x="438912" y="2331720"/>
+            <a:ext cx="2304288" cy="292608"/>
+          </a:xfrm>
+          <a:prstGeom prst="rect">
+            <a:avLst/>
+          </a:prstGeom>
+          <a:noFill/>
+          <a:ln/>
+        </p:spPr>
+        <p:txBody>
+          <a:bodyPr wrap="square" lIns="0" tIns="0" rIns="0" bIns="0" rtlCol="0" anchor="ctr"/>
+          <a:lstStyle/>
+          <a:p>
+            <a:pPr indent="0" marL="0">
+              <a:buNone/>
+            </a:pPr>
+            <a:r>
+              <a:rPr lang="en-US" sz="1000" b="1" dirty="0">
                 <a:solidFill>
                   <a:srgbClr val="FFFFFF"/>
                 </a:solidFill>
@@ -14197,181 +15266,96 @@
                 <a:ea typeface="Calibri" pitchFamily="34" charset="-122"/>
                 <a:cs typeface="Calibri" pitchFamily="34" charset="-120"/>
               </a:rPr>
-              <a:t>Site C</a:t>
-            </a:r>
-            <a:endParaRPr lang="en-US" sz="750" dirty="0"/>
-          </a:p>
-        </p:txBody>
-      </p:sp>
-      <p:sp>
-        <p:nvSpPr>
-          <p:cNvPr id="21" name="Text 19"/>
-          <p:cNvSpPr/>
-          <p:nvPr/>
-        </p:nvSpPr>
-        <p:spPr>
-          <a:xfrm>
-            <a:off x="960120" y="2971800"/>
-            <a:ext cx="3383280" cy="384048"/>
-          </a:xfrm>
-          <a:prstGeom prst="rect">
-            <a:avLst/>
-          </a:prstGeom>
-          <a:noFill/>
-          <a:ln/>
-        </p:spPr>
-        <p:txBody>
-          <a:bodyPr wrap="square" lIns="0" tIns="0" rIns="0" bIns="0" rtlCol="0" anchor="ctr"/>
-          <a:lstStyle/>
-          <a:p>
-            <a:pPr indent="0" marL="0">
-              <a:buNone/>
-            </a:pPr>
-            <a:r>
-              <a:rPr lang="en-US" sz="1300" b="1" dirty="0">
-                <a:solidFill>
-                  <a:srgbClr val="0F172A"/>
-                </a:solidFill>
-                <a:latin typeface="Calibri" pitchFamily="34" charset="0"/>
-                <a:ea typeface="Calibri" pitchFamily="34" charset="-122"/>
-                <a:cs typeface="Calibri" pitchFamily="34" charset="-120"/>
-              </a:rPr>
-              <a:t>📡  Telemetry Simulator</a:t>
-            </a:r>
-            <a:endParaRPr lang="en-US" sz="1300" dirty="0"/>
-          </a:p>
-        </p:txBody>
-      </p:sp>
-      <p:sp>
-        <p:nvSpPr>
-          <p:cNvPr id="22" name="Text 20"/>
-          <p:cNvSpPr/>
-          <p:nvPr/>
-        </p:nvSpPr>
-        <p:spPr>
-          <a:xfrm>
-            <a:off x="960120" y="3355848"/>
-            <a:ext cx="3383280" cy="256032"/>
-          </a:xfrm>
-          <a:prstGeom prst="rect">
-            <a:avLst/>
-          </a:prstGeom>
-          <a:noFill/>
-          <a:ln/>
-        </p:spPr>
-        <p:txBody>
-          <a:bodyPr wrap="square" lIns="0" tIns="0" rIns="0" bIns="0" rtlCol="0" anchor="ctr"/>
-          <a:lstStyle/>
-          <a:p>
-            <a:pPr indent="0" marL="0">
-              <a:buNone/>
-            </a:pPr>
-            <a:r>
-              <a:rPr lang="en-US" sz="950" dirty="0">
-                <a:solidFill>
-                  <a:srgbClr val="10B981"/>
-                </a:solidFill>
-                <a:latin typeface="Consolas" pitchFamily="34" charset="0"/>
-                <a:ea typeface="Consolas" pitchFamily="34" charset="-122"/>
-                <a:cs typeface="Consolas" pitchFamily="34" charset="-120"/>
-              </a:rPr>
-              <a:t>localhost:3003</a:t>
-            </a:r>
-            <a:endParaRPr lang="en-US" sz="950" dirty="0"/>
-          </a:p>
-        </p:txBody>
-      </p:sp>
-      <p:sp>
-        <p:nvSpPr>
-          <p:cNvPr id="23" name="Text 21"/>
-          <p:cNvSpPr/>
-          <p:nvPr/>
-        </p:nvSpPr>
-        <p:spPr>
-          <a:xfrm>
-            <a:off x="502920" y="3657600"/>
-            <a:ext cx="3840480" cy="594360"/>
-          </a:xfrm>
-          <a:prstGeom prst="rect">
-            <a:avLst/>
-          </a:prstGeom>
-          <a:noFill/>
-          <a:ln/>
-        </p:spPr>
-        <p:txBody>
-          <a:bodyPr wrap="square" lIns="0" tIns="0" rIns="0" bIns="0" rtlCol="0" anchor="ctr"/>
-          <a:lstStyle/>
-          <a:p>
-            <a:pPr indent="0" marL="0">
-              <a:buNone/>
-            </a:pPr>
-            <a:r>
-              <a:rPr lang="en-US" sz="1050" dirty="0">
-                <a:solidFill>
-                  <a:srgbClr val="475569"/>
-                </a:solidFill>
-                <a:latin typeface="Calibri" pitchFamily="34" charset="0"/>
-                <a:ea typeface="Calibri" pitchFamily="34" charset="-122"/>
-                <a:cs typeface="Calibri" pitchFamily="34" charset="-120"/>
-              </a:rPr>
-              <a:t>Simulate car GPS, dealership visits, and rental events firing into the CDP</a:t>
-            </a:r>
-            <a:endParaRPr lang="en-US" sz="1050" dirty="0"/>
-          </a:p>
-        </p:txBody>
-      </p:sp>
-      <p:sp>
-        <p:nvSpPr>
-          <p:cNvPr id="24" name="Shape 22"/>
-          <p:cNvSpPr/>
-          <p:nvPr/>
-        </p:nvSpPr>
-        <p:spPr>
-          <a:xfrm>
-            <a:off x="4663440" y="2788920"/>
-            <a:ext cx="4114800" cy="1600200"/>
-          </a:xfrm>
-          <a:prstGeom prst="rect">
-            <a:avLst/>
-          </a:prstGeom>
-          <a:solidFill>
-            <a:srgbClr val="FFFFFF"/>
-          </a:solidFill>
-          <a:ln w="19050">
+              <a:t>Signal</a:t>
+            </a:r>
+            <a:endParaRPr lang="en-US" sz="1000" dirty="0"/>
+          </a:p>
+        </p:txBody>
+      </p:sp>
+      <p:sp>
+        <p:nvSpPr>
+          <p:cNvPr id="14" name="Shape 12"/>
+          <p:cNvSpPr/>
+          <p:nvPr/>
+        </p:nvSpPr>
+        <p:spPr>
+          <a:xfrm>
+            <a:off x="2788920" y="2331720"/>
+            <a:ext cx="2194560" cy="292608"/>
+          </a:xfrm>
+          <a:prstGeom prst="rect">
+            <a:avLst/>
+          </a:prstGeom>
+          <a:solidFill>
+            <a:srgbClr val="0F172A"/>
+          </a:solidFill>
+          <a:ln w="12700">
             <a:solidFill>
-              <a:srgbClr val="8B5CF6"/>
+              <a:srgbClr val="0F172A"/>
             </a:solidFill>
             <a:prstDash val="solid"/>
           </a:ln>
-          <a:effectLst>
-            <a:outerShdw sx="100000" sy="100000" kx="0" ky="0" algn="bl" rotWithShape="0" blurRad="101600" dist="38100" dir="8100000">
-              <a:srgbClr val="000000">
-                <a:alpha val="25000"/>
-              </a:srgbClr>
-            </a:outerShdw>
-          </a:effectLst>
-        </p:spPr>
-      </p:sp>
-      <p:sp>
-        <p:nvSpPr>
-          <p:cNvPr id="25" name="Shape 23"/>
-          <p:cNvSpPr/>
-          <p:nvPr/>
-        </p:nvSpPr>
-        <p:spPr>
-          <a:xfrm>
-            <a:off x="4663440" y="2788920"/>
-            <a:ext cx="4114800" cy="91440"/>
-          </a:xfrm>
-          <a:prstGeom prst="rect">
-            <a:avLst/>
-          </a:prstGeom>
-          <a:solidFill>
-            <a:srgbClr val="8B5CF6"/>
+        </p:spPr>
+      </p:sp>
+      <p:sp>
+        <p:nvSpPr>
+          <p:cNvPr id="15" name="Text 13"/>
+          <p:cNvSpPr/>
+          <p:nvPr/>
+        </p:nvSpPr>
+        <p:spPr>
+          <a:xfrm>
+            <a:off x="2862072" y="2331720"/>
+            <a:ext cx="2121408" cy="292608"/>
+          </a:xfrm>
+          <a:prstGeom prst="rect">
+            <a:avLst/>
+          </a:prstGeom>
+          <a:noFill/>
+          <a:ln/>
+        </p:spPr>
+        <p:txBody>
+          <a:bodyPr wrap="square" lIns="0" tIns="0" rIns="0" bIns="0" rtlCol="0" anchor="ctr"/>
+          <a:lstStyle/>
+          <a:p>
+            <a:pPr indent="0" marL="0">
+              <a:buNone/>
+            </a:pPr>
+            <a:r>
+              <a:rPr lang="en-US" sz="1000" b="1" dirty="0">
+                <a:solidFill>
+                  <a:srgbClr val="FFFFFF"/>
+                </a:solidFill>
+                <a:latin typeface="Calibri" pitchFamily="34" charset="0"/>
+                <a:ea typeface="Calibri" pitchFamily="34" charset="-122"/>
+                <a:cs typeface="Calibri" pitchFamily="34" charset="-120"/>
+              </a:rPr>
+              <a:t>Offer</a:t>
+            </a:r>
+            <a:endParaRPr lang="en-US" sz="1000" dirty="0"/>
+          </a:p>
+        </p:txBody>
+      </p:sp>
+      <p:sp>
+        <p:nvSpPr>
+          <p:cNvPr id="16" name="Shape 14"/>
+          <p:cNvSpPr/>
+          <p:nvPr/>
+        </p:nvSpPr>
+        <p:spPr>
+          <a:xfrm>
+            <a:off x="5029200" y="2331720"/>
+            <a:ext cx="3246120" cy="292608"/>
+          </a:xfrm>
+          <a:prstGeom prst="rect">
+            <a:avLst/>
+          </a:prstGeom>
+          <a:solidFill>
+            <a:srgbClr val="0F172A"/>
           </a:solidFill>
           <a:ln w="12700">
             <a:solidFill>
-              <a:srgbClr val="8B5CF6"/>
+              <a:srgbClr val="0F172A"/>
             </a:solidFill>
             <a:prstDash val="solid"/>
           </a:ln>
@@ -14379,24 +15363,63 @@
       </p:sp>
       <p:sp>
         <p:nvSpPr>
-          <p:cNvPr id="26" name="Shape 24"/>
-          <p:cNvSpPr/>
-          <p:nvPr/>
-        </p:nvSpPr>
-        <p:spPr>
-          <a:xfrm>
-            <a:off x="4800600" y="2971800"/>
-            <a:ext cx="384048" cy="384048"/>
-          </a:xfrm>
-          <a:prstGeom prst="ellipse">
-            <a:avLst/>
-          </a:prstGeom>
-          <a:solidFill>
-            <a:srgbClr val="8B5CF6"/>
+          <p:cNvPr id="17" name="Text 15"/>
+          <p:cNvSpPr/>
+          <p:nvPr/>
+        </p:nvSpPr>
+        <p:spPr>
+          <a:xfrm>
+            <a:off x="5102352" y="2331720"/>
+            <a:ext cx="3172968" cy="292608"/>
+          </a:xfrm>
+          <a:prstGeom prst="rect">
+            <a:avLst/>
+          </a:prstGeom>
+          <a:noFill/>
+          <a:ln/>
+        </p:spPr>
+        <p:txBody>
+          <a:bodyPr wrap="square" lIns="0" tIns="0" rIns="0" bIns="0" rtlCol="0" anchor="ctr"/>
+          <a:lstStyle/>
+          <a:p>
+            <a:pPr indent="0" marL="0">
+              <a:buNone/>
+            </a:pPr>
+            <a:r>
+              <a:rPr lang="en-US" sz="1000" b="1" dirty="0">
+                <a:solidFill>
+                  <a:srgbClr val="FFFFFF"/>
+                </a:solidFill>
+                <a:latin typeface="Calibri" pitchFamily="34" charset="0"/>
+                <a:ea typeface="Calibri" pitchFamily="34" charset="-122"/>
+                <a:cs typeface="Calibri" pitchFamily="34" charset="-120"/>
+              </a:rPr>
+              <a:t>Surface / Detail</a:t>
+            </a:r>
+            <a:endParaRPr lang="en-US" sz="1000" dirty="0"/>
+          </a:p>
+        </p:txBody>
+      </p:sp>
+      <p:sp>
+        <p:nvSpPr>
+          <p:cNvPr id="18" name="Shape 16"/>
+          <p:cNvSpPr/>
+          <p:nvPr/>
+        </p:nvSpPr>
+        <p:spPr>
+          <a:xfrm>
+            <a:off x="365760" y="2624328"/>
+            <a:ext cx="2377440" cy="347472"/>
+          </a:xfrm>
+          <a:prstGeom prst="rect">
+            <a:avLst/>
+          </a:prstGeom>
+          <a:solidFill>
+            <a:srgbClr val="FFFFFF"/>
           </a:solidFill>
           <a:ln w="12700">
             <a:solidFill>
-              <a:srgbClr val="8B5CF6"/>
+              <a:srgbClr val="E2E8F0"/>
             </a:solidFill>
             <a:prstDash val="solid"/>
           </a:ln>
@@ -14404,14 +15427,1291 @@
       </p:sp>
       <p:sp>
         <p:nvSpPr>
+          <p:cNvPr id="19" name="Shape 17"/>
+          <p:cNvSpPr/>
+          <p:nvPr/>
+        </p:nvSpPr>
+        <p:spPr>
+          <a:xfrm>
+            <a:off x="365760" y="2624328"/>
+            <a:ext cx="64008" cy="347472"/>
+          </a:xfrm>
+          <a:prstGeom prst="rect">
+            <a:avLst/>
+          </a:prstGeom>
+          <a:solidFill>
+            <a:srgbClr val="6366F1"/>
+          </a:solidFill>
+          <a:ln w="12700">
+            <a:solidFill>
+              <a:srgbClr val="6366F1"/>
+            </a:solidFill>
+            <a:prstDash val="solid"/>
+          </a:ln>
+        </p:spPr>
+      </p:sp>
+      <p:sp>
+        <p:nvSpPr>
+          <p:cNvPr id="20" name="Text 18"/>
+          <p:cNvSpPr/>
+          <p:nvPr/>
+        </p:nvSpPr>
+        <p:spPr>
+          <a:xfrm>
+            <a:off x="493776" y="2624328"/>
+            <a:ext cx="2212848" cy="347472"/>
+          </a:xfrm>
+          <a:prstGeom prst="rect">
+            <a:avLst/>
+          </a:prstGeom>
+          <a:noFill/>
+          <a:ln/>
+        </p:spPr>
+        <p:txBody>
+          <a:bodyPr wrap="square" lIns="0" tIns="0" rIns="0" bIns="0" rtlCol="0" anchor="ctr"/>
+          <a:lstStyle/>
+          <a:p>
+            <a:pPr indent="0" marL="0">
+              <a:buNone/>
+            </a:pPr>
+            <a:r>
+              <a:rPr lang="en-US" sz="900" dirty="0">
+                <a:solidFill>
+                  <a:srgbClr val="0F172A"/>
+                </a:solidFill>
+                <a:latin typeface="Calibri" pitchFamily="34" charset="0"/>
+                <a:ea typeface="Calibri" pitchFamily="34" charset="-122"/>
+                <a:cs typeface="Calibri" pitchFamily="34" charset="-120"/>
+              </a:rPr>
+              <a:t>High Purchase Intent</a:t>
+            </a:r>
+            <a:endParaRPr lang="en-US" sz="900" dirty="0"/>
+          </a:p>
+        </p:txBody>
+      </p:sp>
+      <p:sp>
+        <p:nvSpPr>
+          <p:cNvPr id="21" name="Shape 19"/>
+          <p:cNvSpPr/>
+          <p:nvPr/>
+        </p:nvSpPr>
+        <p:spPr>
+          <a:xfrm>
+            <a:off x="2788920" y="2624328"/>
+            <a:ext cx="2194560" cy="347472"/>
+          </a:xfrm>
+          <a:prstGeom prst="rect">
+            <a:avLst/>
+          </a:prstGeom>
+          <a:solidFill>
+            <a:srgbClr val="FFFFFF"/>
+          </a:solidFill>
+          <a:ln w="12700">
+            <a:solidFill>
+              <a:srgbClr val="E2E8F0"/>
+            </a:solidFill>
+            <a:prstDash val="solid"/>
+          </a:ln>
+        </p:spPr>
+      </p:sp>
+      <p:sp>
+        <p:nvSpPr>
+          <p:cNvPr id="22" name="Text 20"/>
+          <p:cNvSpPr/>
+          <p:nvPr/>
+        </p:nvSpPr>
+        <p:spPr>
+          <a:xfrm>
+            <a:off x="2862072" y="2624328"/>
+            <a:ext cx="2084832" cy="347472"/>
+          </a:xfrm>
+          <a:prstGeom prst="rect">
+            <a:avLst/>
+          </a:prstGeom>
+          <a:noFill/>
+          <a:ln/>
+        </p:spPr>
+        <p:txBody>
+          <a:bodyPr wrap="square" lIns="0" tIns="0" rIns="0" bIns="0" rtlCol="0" anchor="ctr"/>
+          <a:lstStyle/>
+          <a:p>
+            <a:pPr indent="0" marL="0">
+              <a:buNone/>
+            </a:pPr>
+            <a:r>
+              <a:rPr lang="en-US" sz="950" b="1" dirty="0">
+                <a:solidFill>
+                  <a:srgbClr val="475569"/>
+                </a:solidFill>
+                <a:latin typeface="Calibri" pitchFamily="34" charset="0"/>
+                <a:ea typeface="Calibri" pitchFamily="34" charset="-122"/>
+                <a:cs typeface="Calibri" pitchFamily="34" charset="-120"/>
+              </a:rPr>
+              <a:t>5% discount</a:t>
+            </a:r>
+            <a:endParaRPr lang="en-US" sz="950" dirty="0"/>
+          </a:p>
+        </p:txBody>
+      </p:sp>
+      <p:sp>
+        <p:nvSpPr>
+          <p:cNvPr id="23" name="Shape 21"/>
+          <p:cNvSpPr/>
+          <p:nvPr/>
+        </p:nvSpPr>
+        <p:spPr>
+          <a:xfrm>
+            <a:off x="5029200" y="2624328"/>
+            <a:ext cx="3246120" cy="347472"/>
+          </a:xfrm>
+          <a:prstGeom prst="rect">
+            <a:avLst/>
+          </a:prstGeom>
+          <a:solidFill>
+            <a:srgbClr val="FFFFFF"/>
+          </a:solidFill>
+          <a:ln w="12700">
+            <a:solidFill>
+              <a:srgbClr val="E2E8F0"/>
+            </a:solidFill>
+            <a:prstDash val="solid"/>
+          </a:ln>
+        </p:spPr>
+      </p:sp>
+      <p:sp>
+        <p:nvSpPr>
+          <p:cNvPr id="24" name="Text 22"/>
+          <p:cNvSpPr/>
+          <p:nvPr/>
+        </p:nvSpPr>
+        <p:spPr>
+          <a:xfrm>
+            <a:off x="5102352" y="2624328"/>
+            <a:ext cx="3136392" cy="347472"/>
+          </a:xfrm>
+          <a:prstGeom prst="rect">
+            <a:avLst/>
+          </a:prstGeom>
+          <a:noFill/>
+          <a:ln/>
+        </p:spPr>
+        <p:txBody>
+          <a:bodyPr wrap="square" lIns="0" tIns="0" rIns="0" bIns="0" rtlCol="0" anchor="ctr"/>
+          <a:lstStyle/>
+          <a:p>
+            <a:pPr indent="0" marL="0">
+              <a:buNone/>
+            </a:pPr>
+            <a:r>
+              <a:rPr lang="en-US" sz="900" dirty="0">
+                <a:solidFill>
+                  <a:srgbClr val="475569"/>
+                </a:solidFill>
+                <a:latin typeface="Calibri" pitchFamily="34" charset="0"/>
+                <a:ea typeface="Calibri" pitchFamily="34" charset="-122"/>
+                <a:cs typeface="Calibri" pitchFamily="34" charset="-120"/>
+              </a:rPr>
+              <a:t>Gold price on storefront · struck-through MSRP · banner</a:t>
+            </a:r>
+            <a:endParaRPr lang="en-US" sz="900" dirty="0"/>
+          </a:p>
+        </p:txBody>
+      </p:sp>
+      <p:sp>
+        <p:nvSpPr>
+          <p:cNvPr id="25" name="Shape 23"/>
+          <p:cNvSpPr/>
+          <p:nvPr/>
+        </p:nvSpPr>
+        <p:spPr>
+          <a:xfrm>
+            <a:off x="365760" y="2971800"/>
+            <a:ext cx="2377440" cy="347472"/>
+          </a:xfrm>
+          <a:prstGeom prst="rect">
+            <a:avLst/>
+          </a:prstGeom>
+          <a:solidFill>
+            <a:srgbClr val="F8FAFC"/>
+          </a:solidFill>
+          <a:ln w="12700">
+            <a:solidFill>
+              <a:srgbClr val="E2E8F0"/>
+            </a:solidFill>
+            <a:prstDash val="solid"/>
+          </a:ln>
+        </p:spPr>
+      </p:sp>
+      <p:sp>
+        <p:nvSpPr>
+          <p:cNvPr id="26" name="Shape 24"/>
+          <p:cNvSpPr/>
+          <p:nvPr/>
+        </p:nvSpPr>
+        <p:spPr>
+          <a:xfrm>
+            <a:off x="365760" y="2971800"/>
+            <a:ext cx="64008" cy="347472"/>
+          </a:xfrm>
+          <a:prstGeom prst="rect">
+            <a:avLst/>
+          </a:prstGeom>
+          <a:solidFill>
+            <a:srgbClr val="7C3AED"/>
+          </a:solidFill>
+          <a:ln w="12700">
+            <a:solidFill>
+              <a:srgbClr val="7C3AED"/>
+            </a:solidFill>
+            <a:prstDash val="solid"/>
+          </a:ln>
+        </p:spPr>
+      </p:sp>
+      <p:sp>
+        <p:nvSpPr>
           <p:cNvPr id="27" name="Text 25"/>
           <p:cNvSpPr/>
           <p:nvPr/>
         </p:nvSpPr>
         <p:spPr>
           <a:xfrm>
-            <a:off x="4800600" y="2971800"/>
-            <a:ext cx="384048" cy="384048"/>
+            <a:off x="493776" y="2971800"/>
+            <a:ext cx="2212848" cy="347472"/>
+          </a:xfrm>
+          <a:prstGeom prst="rect">
+            <a:avLst/>
+          </a:prstGeom>
+          <a:noFill/>
+          <a:ln/>
+        </p:spPr>
+        <p:txBody>
+          <a:bodyPr wrap="square" lIns="0" tIns="0" rIns="0" bIns="0" rtlCol="0" anchor="ctr"/>
+          <a:lstStyle/>
+          <a:p>
+            <a:pPr indent="0" marL="0">
+              <a:buNone/>
+            </a:pPr>
+            <a:r>
+              <a:rPr lang="en-US" sz="900" dirty="0">
+                <a:solidFill>
+                  <a:srgbClr val="0F172A"/>
+                </a:solidFill>
+                <a:latin typeface="Calibri" pitchFamily="34" charset="0"/>
+                <a:ea typeface="Calibri" pitchFamily="34" charset="-122"/>
+                <a:cs typeface="Calibri" pitchFamily="34" charset="-120"/>
+              </a:rPr>
+              <a:t>Loyalty Milestone</a:t>
+            </a:r>
+            <a:endParaRPr lang="en-US" sz="900" dirty="0"/>
+          </a:p>
+        </p:txBody>
+      </p:sp>
+      <p:sp>
+        <p:nvSpPr>
+          <p:cNvPr id="28" name="Shape 26"/>
+          <p:cNvSpPr/>
+          <p:nvPr/>
+        </p:nvSpPr>
+        <p:spPr>
+          <a:xfrm>
+            <a:off x="2788920" y="2971800"/>
+            <a:ext cx="2194560" cy="347472"/>
+          </a:xfrm>
+          <a:prstGeom prst="rect">
+            <a:avLst/>
+          </a:prstGeom>
+          <a:solidFill>
+            <a:srgbClr val="F8FAFC"/>
+          </a:solidFill>
+          <a:ln w="12700">
+            <a:solidFill>
+              <a:srgbClr val="E2E8F0"/>
+            </a:solidFill>
+            <a:prstDash val="solid"/>
+          </a:ln>
+        </p:spPr>
+      </p:sp>
+      <p:sp>
+        <p:nvSpPr>
+          <p:cNvPr id="29" name="Text 27"/>
+          <p:cNvSpPr/>
+          <p:nvPr/>
+        </p:nvSpPr>
+        <p:spPr>
+          <a:xfrm>
+            <a:off x="2862072" y="2971800"/>
+            <a:ext cx="2084832" cy="347472"/>
+          </a:xfrm>
+          <a:prstGeom prst="rect">
+            <a:avLst/>
+          </a:prstGeom>
+          <a:noFill/>
+          <a:ln/>
+        </p:spPr>
+        <p:txBody>
+          <a:bodyPr wrap="square" lIns="0" tIns="0" rIns="0" bIns="0" rtlCol="0" anchor="ctr"/>
+          <a:lstStyle/>
+          <a:p>
+            <a:pPr indent="0" marL="0">
+              <a:buNone/>
+            </a:pPr>
+            <a:r>
+              <a:rPr lang="en-US" sz="950" b="1" dirty="0">
+                <a:solidFill>
+                  <a:srgbClr val="475569"/>
+                </a:solidFill>
+                <a:latin typeface="Calibri" pitchFamily="34" charset="0"/>
+                <a:ea typeface="Calibri" pitchFamily="34" charset="-122"/>
+                <a:cs typeface="Calibri" pitchFamily="34" charset="-120"/>
+              </a:rPr>
+              <a:t>Double Points Weekend</a:t>
+            </a:r>
+            <a:endParaRPr lang="en-US" sz="950" dirty="0"/>
+          </a:p>
+        </p:txBody>
+      </p:sp>
+      <p:sp>
+        <p:nvSpPr>
+          <p:cNvPr id="30" name="Shape 28"/>
+          <p:cNvSpPr/>
+          <p:nvPr/>
+        </p:nvSpPr>
+        <p:spPr>
+          <a:xfrm>
+            <a:off x="5029200" y="2971800"/>
+            <a:ext cx="3246120" cy="347472"/>
+          </a:xfrm>
+          <a:prstGeom prst="rect">
+            <a:avLst/>
+          </a:prstGeom>
+          <a:solidFill>
+            <a:srgbClr val="F8FAFC"/>
+          </a:solidFill>
+          <a:ln w="12700">
+            <a:solidFill>
+              <a:srgbClr val="E2E8F0"/>
+            </a:solidFill>
+            <a:prstDash val="solid"/>
+          </a:ln>
+        </p:spPr>
+      </p:sp>
+      <p:sp>
+        <p:nvSpPr>
+          <p:cNvPr id="31" name="Text 29"/>
+          <p:cNvSpPr/>
+          <p:nvPr/>
+        </p:nvSpPr>
+        <p:spPr>
+          <a:xfrm>
+            <a:off x="5102352" y="2971800"/>
+            <a:ext cx="3136392" cy="347472"/>
+          </a:xfrm>
+          <a:prstGeom prst="rect">
+            <a:avLst/>
+          </a:prstGeom>
+          <a:noFill/>
+          <a:ln/>
+        </p:spPr>
+        <p:txBody>
+          <a:bodyPr wrap="square" lIns="0" tIns="0" rIns="0" bIns="0" rtlCol="0" anchor="ctr"/>
+          <a:lstStyle/>
+          <a:p>
+            <a:pPr indent="0" marL="0">
+              <a:buNone/>
+            </a:pPr>
+            <a:r>
+              <a:rPr lang="en-US" sz="900" dirty="0">
+                <a:solidFill>
+                  <a:srgbClr val="475569"/>
+                </a:solidFill>
+                <a:latin typeface="Calibri" pitchFamily="34" charset="0"/>
+                <a:ea typeface="Calibri" pitchFamily="34" charset="-122"/>
+                <a:cs typeface="Calibri" pitchFamily="34" charset="-120"/>
+              </a:rPr>
+              <a:t>Book service this week to unlock the next tier</a:t>
+            </a:r>
+            <a:endParaRPr lang="en-US" sz="900" dirty="0"/>
+          </a:p>
+        </p:txBody>
+      </p:sp>
+      <p:sp>
+        <p:nvSpPr>
+          <p:cNvPr id="32" name="Shape 30"/>
+          <p:cNvSpPr/>
+          <p:nvPr/>
+        </p:nvSpPr>
+        <p:spPr>
+          <a:xfrm>
+            <a:off x="365760" y="3319272"/>
+            <a:ext cx="2377440" cy="347472"/>
+          </a:xfrm>
+          <a:prstGeom prst="rect">
+            <a:avLst/>
+          </a:prstGeom>
+          <a:solidFill>
+            <a:srgbClr val="FFFFFF"/>
+          </a:solidFill>
+          <a:ln w="12700">
+            <a:solidFill>
+              <a:srgbClr val="E2E8F0"/>
+            </a:solidFill>
+            <a:prstDash val="solid"/>
+          </a:ln>
+        </p:spPr>
+      </p:sp>
+      <p:sp>
+        <p:nvSpPr>
+          <p:cNvPr id="33" name="Shape 31"/>
+          <p:cNvSpPr/>
+          <p:nvPr/>
+        </p:nvSpPr>
+        <p:spPr>
+          <a:xfrm>
+            <a:off x="365760" y="3319272"/>
+            <a:ext cx="64008" cy="347472"/>
+          </a:xfrm>
+          <a:prstGeom prst="rect">
+            <a:avLst/>
+          </a:prstGeom>
+          <a:solidFill>
+            <a:srgbClr val="F59E0B"/>
+          </a:solidFill>
+          <a:ln w="12700">
+            <a:solidFill>
+              <a:srgbClr val="F59E0B"/>
+            </a:solidFill>
+            <a:prstDash val="solid"/>
+          </a:ln>
+        </p:spPr>
+      </p:sp>
+      <p:sp>
+        <p:nvSpPr>
+          <p:cNvPr id="34" name="Text 32"/>
+          <p:cNvSpPr/>
+          <p:nvPr/>
+        </p:nvSpPr>
+        <p:spPr>
+          <a:xfrm>
+            <a:off x="493776" y="3319272"/>
+            <a:ext cx="2212848" cy="347472"/>
+          </a:xfrm>
+          <a:prstGeom prst="rect">
+            <a:avLst/>
+          </a:prstGeom>
+          <a:noFill/>
+          <a:ln/>
+        </p:spPr>
+        <p:txBody>
+          <a:bodyPr wrap="square" lIns="0" tIns="0" rIns="0" bIns="0" rtlCol="0" anchor="ctr"/>
+          <a:lstStyle/>
+          <a:p>
+            <a:pPr indent="0" marL="0">
+              <a:buNone/>
+            </a:pPr>
+            <a:r>
+              <a:rPr lang="en-US" sz="900" dirty="0">
+                <a:solidFill>
+                  <a:srgbClr val="0F172A"/>
+                </a:solidFill>
+                <a:latin typeface="Calibri" pitchFamily="34" charset="0"/>
+                <a:ea typeface="Calibri" pitchFamily="34" charset="-122"/>
+                <a:cs typeface="Calibri" pitchFamily="34" charset="-120"/>
+              </a:rPr>
+              <a:t>Active Driver</a:t>
+            </a:r>
+            <a:endParaRPr lang="en-US" sz="900" dirty="0"/>
+          </a:p>
+        </p:txBody>
+      </p:sp>
+      <p:sp>
+        <p:nvSpPr>
+          <p:cNvPr id="35" name="Shape 33"/>
+          <p:cNvSpPr/>
+          <p:nvPr/>
+        </p:nvSpPr>
+        <p:spPr>
+          <a:xfrm>
+            <a:off x="2788920" y="3319272"/>
+            <a:ext cx="2194560" cy="347472"/>
+          </a:xfrm>
+          <a:prstGeom prst="rect">
+            <a:avLst/>
+          </a:prstGeom>
+          <a:solidFill>
+            <a:srgbClr val="FFFFFF"/>
+          </a:solidFill>
+          <a:ln w="12700">
+            <a:solidFill>
+              <a:srgbClr val="E2E8F0"/>
+            </a:solidFill>
+            <a:prstDash val="solid"/>
+          </a:ln>
+        </p:spPr>
+      </p:sp>
+      <p:sp>
+        <p:nvSpPr>
+          <p:cNvPr id="36" name="Text 34"/>
+          <p:cNvSpPr/>
+          <p:nvPr/>
+        </p:nvSpPr>
+        <p:spPr>
+          <a:xfrm>
+            <a:off x="2862072" y="3319272"/>
+            <a:ext cx="2084832" cy="347472"/>
+          </a:xfrm>
+          <a:prstGeom prst="rect">
+            <a:avLst/>
+          </a:prstGeom>
+          <a:noFill/>
+          <a:ln/>
+        </p:spPr>
+        <p:txBody>
+          <a:bodyPr wrap="square" lIns="0" tIns="0" rIns="0" bIns="0" rtlCol="0" anchor="ctr"/>
+          <a:lstStyle/>
+          <a:p>
+            <a:pPr indent="0" marL="0">
+              <a:buNone/>
+            </a:pPr>
+            <a:r>
+              <a:rPr lang="en-US" sz="950" b="1" dirty="0">
+                <a:solidFill>
+                  <a:srgbClr val="475569"/>
+                </a:solidFill>
+                <a:latin typeface="Calibri" pitchFamily="34" charset="0"/>
+                <a:ea typeface="Calibri" pitchFamily="34" charset="-122"/>
+                <a:cs typeface="Calibri" pitchFamily="34" charset="-120"/>
+              </a:rPr>
+              <a:t>3× Rental Points + 500 Service Pts</a:t>
+            </a:r>
+            <a:endParaRPr lang="en-US" sz="950" dirty="0"/>
+          </a:p>
+        </p:txBody>
+      </p:sp>
+      <p:sp>
+        <p:nvSpPr>
+          <p:cNvPr id="37" name="Shape 35"/>
+          <p:cNvSpPr/>
+          <p:nvPr/>
+        </p:nvSpPr>
+        <p:spPr>
+          <a:xfrm>
+            <a:off x="5029200" y="3319272"/>
+            <a:ext cx="3246120" cy="347472"/>
+          </a:xfrm>
+          <a:prstGeom prst="rect">
+            <a:avLst/>
+          </a:prstGeom>
+          <a:solidFill>
+            <a:srgbClr val="FFFFFF"/>
+          </a:solidFill>
+          <a:ln w="12700">
+            <a:solidFill>
+              <a:srgbClr val="E2E8F0"/>
+            </a:solidFill>
+            <a:prstDash val="solid"/>
+          </a:ln>
+        </p:spPr>
+      </p:sp>
+      <p:sp>
+        <p:nvSpPr>
+          <p:cNvPr id="38" name="Text 36"/>
+          <p:cNvSpPr/>
+          <p:nvPr/>
+        </p:nvSpPr>
+        <p:spPr>
+          <a:xfrm>
+            <a:off x="5102352" y="3319272"/>
+            <a:ext cx="3136392" cy="347472"/>
+          </a:xfrm>
+          <a:prstGeom prst="rect">
+            <a:avLst/>
+          </a:prstGeom>
+          <a:noFill/>
+          <a:ln/>
+        </p:spPr>
+        <p:txBody>
+          <a:bodyPr wrap="square" lIns="0" tIns="0" rIns="0" bIns="0" rtlCol="0" anchor="ctr"/>
+          <a:lstStyle/>
+          <a:p>
+            <a:pPr indent="0" marL="0">
+              <a:buNone/>
+            </a:pPr>
+            <a:r>
+              <a:rPr lang="en-US" sz="900" dirty="0">
+                <a:solidFill>
+                  <a:srgbClr val="475569"/>
+                </a:solidFill>
+                <a:latin typeface="Calibri" pitchFamily="34" charset="0"/>
+                <a:ea typeface="Calibri" pitchFamily="34" charset="-122"/>
+                <a:cs typeface="Calibri" pitchFamily="34" charset="-120"/>
+              </a:rPr>
+              <a:t>Two separate offer cards appear simultaneously</a:t>
+            </a:r>
+            <a:endParaRPr lang="en-US" sz="900" dirty="0"/>
+          </a:p>
+        </p:txBody>
+      </p:sp>
+      <p:sp>
+        <p:nvSpPr>
+          <p:cNvPr id="39" name="Shape 37"/>
+          <p:cNvSpPr/>
+          <p:nvPr/>
+        </p:nvSpPr>
+        <p:spPr>
+          <a:xfrm>
+            <a:off x="365760" y="3666744"/>
+            <a:ext cx="2377440" cy="347472"/>
+          </a:xfrm>
+          <a:prstGeom prst="rect">
+            <a:avLst/>
+          </a:prstGeom>
+          <a:solidFill>
+            <a:srgbClr val="F8FAFC"/>
+          </a:solidFill>
+          <a:ln w="12700">
+            <a:solidFill>
+              <a:srgbClr val="E2E8F0"/>
+            </a:solidFill>
+            <a:prstDash val="solid"/>
+          </a:ln>
+        </p:spPr>
+      </p:sp>
+      <p:sp>
+        <p:nvSpPr>
+          <p:cNvPr id="40" name="Shape 38"/>
+          <p:cNvSpPr/>
+          <p:nvPr/>
+        </p:nvSpPr>
+        <p:spPr>
+          <a:xfrm>
+            <a:off x="365760" y="3666744"/>
+            <a:ext cx="64008" cy="347472"/>
+          </a:xfrm>
+          <a:prstGeom prst="rect">
+            <a:avLst/>
+          </a:prstGeom>
+          <a:solidFill>
+            <a:srgbClr val="0D9488"/>
+          </a:solidFill>
+          <a:ln w="12700">
+            <a:solidFill>
+              <a:srgbClr val="0D9488"/>
+            </a:solidFill>
+            <a:prstDash val="solid"/>
+          </a:ln>
+        </p:spPr>
+      </p:sp>
+      <p:sp>
+        <p:nvSpPr>
+          <p:cNvPr id="41" name="Text 39"/>
+          <p:cNvSpPr/>
+          <p:nvPr/>
+        </p:nvSpPr>
+        <p:spPr>
+          <a:xfrm>
+            <a:off x="493776" y="3666744"/>
+            <a:ext cx="2212848" cy="347472"/>
+          </a:xfrm>
+          <a:prstGeom prst="rect">
+            <a:avLst/>
+          </a:prstGeom>
+          <a:noFill/>
+          <a:ln/>
+        </p:spPr>
+        <p:txBody>
+          <a:bodyPr wrap="square" lIns="0" tIns="0" rIns="0" bIns="0" rtlCol="0" anchor="ctr"/>
+          <a:lstStyle/>
+          <a:p>
+            <a:pPr indent="0" marL="0">
+              <a:buNone/>
+            </a:pPr>
+            <a:r>
+              <a:rPr lang="en-US" sz="900" dirty="0">
+                <a:solidFill>
+                  <a:srgbClr val="0F172A"/>
+                </a:solidFill>
+                <a:latin typeface="Calibri" pitchFamily="34" charset="0"/>
+                <a:ea typeface="Calibri" pitchFamily="34" charset="-122"/>
+                <a:cs typeface="Calibri" pitchFamily="34" charset="-120"/>
+              </a:rPr>
+              <a:t>Recent Renter Browsing</a:t>
+            </a:r>
+            <a:endParaRPr lang="en-US" sz="900" dirty="0"/>
+          </a:p>
+        </p:txBody>
+      </p:sp>
+      <p:sp>
+        <p:nvSpPr>
+          <p:cNvPr id="42" name="Shape 40"/>
+          <p:cNvSpPr/>
+          <p:nvPr/>
+        </p:nvSpPr>
+        <p:spPr>
+          <a:xfrm>
+            <a:off x="2788920" y="3666744"/>
+            <a:ext cx="2194560" cy="347472"/>
+          </a:xfrm>
+          <a:prstGeom prst="rect">
+            <a:avLst/>
+          </a:prstGeom>
+          <a:solidFill>
+            <a:srgbClr val="F8FAFC"/>
+          </a:solidFill>
+          <a:ln w="12700">
+            <a:solidFill>
+              <a:srgbClr val="E2E8F0"/>
+            </a:solidFill>
+            <a:prstDash val="solid"/>
+          </a:ln>
+        </p:spPr>
+      </p:sp>
+      <p:sp>
+        <p:nvSpPr>
+          <p:cNvPr id="43" name="Text 41"/>
+          <p:cNvSpPr/>
+          <p:nvPr/>
+        </p:nvSpPr>
+        <p:spPr>
+          <a:xfrm>
+            <a:off x="2862072" y="3666744"/>
+            <a:ext cx="2084832" cy="347472"/>
+          </a:xfrm>
+          <a:prstGeom prst="rect">
+            <a:avLst/>
+          </a:prstGeom>
+          <a:noFill/>
+          <a:ln/>
+        </p:spPr>
+        <p:txBody>
+          <a:bodyPr wrap="square" lIns="0" tIns="0" rIns="0" bIns="0" rtlCol="0" anchor="ctr"/>
+          <a:lstStyle/>
+          <a:p>
+            <a:pPr indent="0" marL="0">
+              <a:buNone/>
+            </a:pPr>
+            <a:r>
+              <a:rPr lang="en-US" sz="950" b="1" dirty="0">
+                <a:solidFill>
+                  <a:srgbClr val="475569"/>
+                </a:solidFill>
+                <a:latin typeface="Calibri" pitchFamily="34" charset="0"/>
+                <a:ea typeface="Calibri" pitchFamily="34" charset="-122"/>
+                <a:cs typeface="Calibri" pitchFamily="34" charset="-120"/>
+              </a:rPr>
+              <a:t>$500 Trade-In Credit</a:t>
+            </a:r>
+            <a:endParaRPr lang="en-US" sz="950" dirty="0"/>
+          </a:p>
+        </p:txBody>
+      </p:sp>
+      <p:sp>
+        <p:nvSpPr>
+          <p:cNvPr id="44" name="Shape 42"/>
+          <p:cNvSpPr/>
+          <p:nvPr/>
+        </p:nvSpPr>
+        <p:spPr>
+          <a:xfrm>
+            <a:off x="5029200" y="3666744"/>
+            <a:ext cx="3246120" cy="347472"/>
+          </a:xfrm>
+          <a:prstGeom prst="rect">
+            <a:avLst/>
+          </a:prstGeom>
+          <a:solidFill>
+            <a:srgbClr val="F8FAFC"/>
+          </a:solidFill>
+          <a:ln w="12700">
+            <a:solidFill>
+              <a:srgbClr val="E2E8F0"/>
+            </a:solidFill>
+            <a:prstDash val="solid"/>
+          </a:ln>
+        </p:spPr>
+      </p:sp>
+      <p:sp>
+        <p:nvSpPr>
+          <p:cNvPr id="45" name="Text 43"/>
+          <p:cNvSpPr/>
+          <p:nvPr/>
+        </p:nvSpPr>
+        <p:spPr>
+          <a:xfrm>
+            <a:off x="5102352" y="3666744"/>
+            <a:ext cx="3136392" cy="347472"/>
+          </a:xfrm>
+          <a:prstGeom prst="rect">
+            <a:avLst/>
+          </a:prstGeom>
+          <a:noFill/>
+          <a:ln/>
+        </p:spPr>
+        <p:txBody>
+          <a:bodyPr wrap="square" lIns="0" tIns="0" rIns="0" bIns="0" rtlCol="0" anchor="ctr"/>
+          <a:lstStyle/>
+          <a:p>
+            <a:pPr indent="0" marL="0">
+              <a:buNone/>
+            </a:pPr>
+            <a:r>
+              <a:rPr lang="en-US" sz="900" dirty="0">
+                <a:solidFill>
+                  <a:srgbClr val="475569"/>
+                </a:solidFill>
+                <a:latin typeface="Calibri" pitchFamily="34" charset="0"/>
+                <a:ea typeface="Calibri" pitchFamily="34" charset="-122"/>
+                <a:cs typeface="Calibri" pitchFamily="34" charset="-120"/>
+              </a:rPr>
+              <a:t>Valid for 30 days toward any new Apex purchase</a:t>
+            </a:r>
+            <a:endParaRPr lang="en-US" sz="900" dirty="0"/>
+          </a:p>
+        </p:txBody>
+      </p:sp>
+      <p:sp>
+        <p:nvSpPr>
+          <p:cNvPr id="46" name="Shape 44"/>
+          <p:cNvSpPr/>
+          <p:nvPr/>
+        </p:nvSpPr>
+        <p:spPr>
+          <a:xfrm>
+            <a:off x="365760" y="4014216"/>
+            <a:ext cx="2377440" cy="347472"/>
+          </a:xfrm>
+          <a:prstGeom prst="rect">
+            <a:avLst/>
+          </a:prstGeom>
+          <a:solidFill>
+            <a:srgbClr val="FFFFFF"/>
+          </a:solidFill>
+          <a:ln w="12700">
+            <a:solidFill>
+              <a:srgbClr val="E2E8F0"/>
+            </a:solidFill>
+            <a:prstDash val="solid"/>
+          </a:ln>
+        </p:spPr>
+      </p:sp>
+      <p:sp>
+        <p:nvSpPr>
+          <p:cNvPr id="47" name="Shape 45"/>
+          <p:cNvSpPr/>
+          <p:nvPr/>
+        </p:nvSpPr>
+        <p:spPr>
+          <a:xfrm>
+            <a:off x="365760" y="4014216"/>
+            <a:ext cx="64008" cy="347472"/>
+          </a:xfrm>
+          <a:prstGeom prst="rect">
+            <a:avLst/>
+          </a:prstGeom>
+          <a:solidFill>
+            <a:srgbClr val="D97706"/>
+          </a:solidFill>
+          <a:ln w="12700">
+            <a:solidFill>
+              <a:srgbClr val="D97706"/>
+            </a:solidFill>
+            <a:prstDash val="solid"/>
+          </a:ln>
+        </p:spPr>
+      </p:sp>
+      <p:sp>
+        <p:nvSpPr>
+          <p:cNvPr id="48" name="Text 46"/>
+          <p:cNvSpPr/>
+          <p:nvPr/>
+        </p:nvSpPr>
+        <p:spPr>
+          <a:xfrm>
+            <a:off x="493776" y="4014216"/>
+            <a:ext cx="2212848" cy="347472"/>
+          </a:xfrm>
+          <a:prstGeom prst="rect">
+            <a:avLst/>
+          </a:prstGeom>
+          <a:noFill/>
+          <a:ln/>
+        </p:spPr>
+        <p:txBody>
+          <a:bodyPr wrap="square" lIns="0" tIns="0" rIns="0" bIns="0" rtlCol="0" anchor="ctr"/>
+          <a:lstStyle/>
+          <a:p>
+            <a:pPr indent="0" marL="0">
+              <a:buNone/>
+            </a:pPr>
+            <a:r>
+              <a:rPr lang="en-US" sz="900" dirty="0">
+                <a:solidFill>
+                  <a:srgbClr val="0F172A"/>
+                </a:solidFill>
+                <a:latin typeface="Calibri" pitchFamily="34" charset="0"/>
+                <a:ea typeface="Calibri" pitchFamily="34" charset="-122"/>
+                <a:cs typeface="Calibri" pitchFamily="34" charset="-120"/>
+              </a:rPr>
+              <a:t>Dealership Walk-In</a:t>
+            </a:r>
+            <a:endParaRPr lang="en-US" sz="900" dirty="0"/>
+          </a:p>
+        </p:txBody>
+      </p:sp>
+      <p:sp>
+        <p:nvSpPr>
+          <p:cNvPr id="49" name="Shape 47"/>
+          <p:cNvSpPr/>
+          <p:nvPr/>
+        </p:nvSpPr>
+        <p:spPr>
+          <a:xfrm>
+            <a:off x="2788920" y="4014216"/>
+            <a:ext cx="2194560" cy="347472"/>
+          </a:xfrm>
+          <a:prstGeom prst="rect">
+            <a:avLst/>
+          </a:prstGeom>
+          <a:solidFill>
+            <a:srgbClr val="FFFFFF"/>
+          </a:solidFill>
+          <a:ln w="12700">
+            <a:solidFill>
+              <a:srgbClr val="E2E8F0"/>
+            </a:solidFill>
+            <a:prstDash val="solid"/>
+          </a:ln>
+        </p:spPr>
+      </p:sp>
+      <p:sp>
+        <p:nvSpPr>
+          <p:cNvPr id="50" name="Text 48"/>
+          <p:cNvSpPr/>
+          <p:nvPr/>
+        </p:nvSpPr>
+        <p:spPr>
+          <a:xfrm>
+            <a:off x="2862072" y="4014216"/>
+            <a:ext cx="2084832" cy="347472"/>
+          </a:xfrm>
+          <a:prstGeom prst="rect">
+            <a:avLst/>
+          </a:prstGeom>
+          <a:noFill/>
+          <a:ln/>
+        </p:spPr>
+        <p:txBody>
+          <a:bodyPr wrap="square" lIns="0" tIns="0" rIns="0" bIns="0" rtlCol="0" anchor="ctr"/>
+          <a:lstStyle/>
+          <a:p>
+            <a:pPr indent="0" marL="0">
+              <a:buNone/>
+            </a:pPr>
+            <a:r>
+              <a:rPr lang="en-US" sz="950" b="1" dirty="0">
+                <a:solidFill>
+                  <a:srgbClr val="475569"/>
+                </a:solidFill>
+                <a:latin typeface="Calibri" pitchFamily="34" charset="0"/>
+                <a:ea typeface="Calibri" pitchFamily="34" charset="-122"/>
+                <a:cs typeface="Calibri" pitchFamily="34" charset="-120"/>
+              </a:rPr>
+              <a:t>In-Store Exclusive (today only)</a:t>
+            </a:r>
+            <a:endParaRPr lang="en-US" sz="950" dirty="0"/>
+          </a:p>
+        </p:txBody>
+      </p:sp>
+      <p:sp>
+        <p:nvSpPr>
+          <p:cNvPr id="51" name="Shape 49"/>
+          <p:cNvSpPr/>
+          <p:nvPr/>
+        </p:nvSpPr>
+        <p:spPr>
+          <a:xfrm>
+            <a:off x="5029200" y="4014216"/>
+            <a:ext cx="3246120" cy="347472"/>
+          </a:xfrm>
+          <a:prstGeom prst="rect">
+            <a:avLst/>
+          </a:prstGeom>
+          <a:solidFill>
+            <a:srgbClr val="FFFFFF"/>
+          </a:solidFill>
+          <a:ln w="12700">
+            <a:solidFill>
+              <a:srgbClr val="E2E8F0"/>
+            </a:solidFill>
+            <a:prstDash val="solid"/>
+          </a:ln>
+        </p:spPr>
+      </p:sp>
+      <p:sp>
+        <p:nvSpPr>
+          <p:cNvPr id="52" name="Text 50"/>
+          <p:cNvSpPr/>
+          <p:nvPr/>
+        </p:nvSpPr>
+        <p:spPr>
+          <a:xfrm>
+            <a:off x="5102352" y="4014216"/>
+            <a:ext cx="3136392" cy="347472"/>
+          </a:xfrm>
+          <a:prstGeom prst="rect">
+            <a:avLst/>
+          </a:prstGeom>
+          <a:noFill/>
+          <a:ln/>
+        </p:spPr>
+        <p:txBody>
+          <a:bodyPr wrap="square" lIns="0" tIns="0" rIns="0" bIns="0" rtlCol="0" anchor="ctr"/>
+          <a:lstStyle/>
+          <a:p>
+            <a:pPr indent="0" marL="0">
+              <a:buNone/>
+            </a:pPr>
+            <a:r>
+              <a:rPr lang="en-US" sz="900" dirty="0">
+                <a:solidFill>
+                  <a:srgbClr val="475569"/>
+                </a:solidFill>
+                <a:latin typeface="Calibri" pitchFamily="34" charset="0"/>
+                <a:ea typeface="Calibri" pitchFamily="34" charset="-122"/>
+                <a:cs typeface="Calibri" pitchFamily="34" charset="-120"/>
+              </a:rPr>
+              <a:t>Pulsing amber badge · free appraisal · $250 accessories credit</a:t>
+            </a:r>
+            <a:endParaRPr lang="en-US" sz="900" dirty="0"/>
+          </a:p>
+        </p:txBody>
+      </p:sp>
+      <p:sp>
+        <p:nvSpPr>
+          <p:cNvPr id="53" name="Shape 51"/>
+          <p:cNvSpPr/>
+          <p:nvPr/>
+        </p:nvSpPr>
+        <p:spPr>
+          <a:xfrm>
+            <a:off x="365760" y="4361688"/>
+            <a:ext cx="2377440" cy="347472"/>
+          </a:xfrm>
+          <a:prstGeom prst="rect">
+            <a:avLst/>
+          </a:prstGeom>
+          <a:solidFill>
+            <a:srgbClr val="F8FAFC"/>
+          </a:solidFill>
+          <a:ln w="12700">
+            <a:solidFill>
+              <a:srgbClr val="E2E8F0"/>
+            </a:solidFill>
+            <a:prstDash val="solid"/>
+          </a:ln>
+        </p:spPr>
+      </p:sp>
+      <p:sp>
+        <p:nvSpPr>
+          <p:cNvPr id="54" name="Shape 52"/>
+          <p:cNvSpPr/>
+          <p:nvPr/>
+        </p:nvSpPr>
+        <p:spPr>
+          <a:xfrm>
+            <a:off x="365760" y="4361688"/>
+            <a:ext cx="64008" cy="347472"/>
+          </a:xfrm>
+          <a:prstGeom prst="rect">
+            <a:avLst/>
+          </a:prstGeom>
+          <a:solidFill>
+            <a:srgbClr val="64748B"/>
+          </a:solidFill>
+          <a:ln w="12700">
+            <a:solidFill>
+              <a:srgbClr val="64748B"/>
+            </a:solidFill>
+            <a:prstDash val="solid"/>
+          </a:ln>
+        </p:spPr>
+      </p:sp>
+      <p:sp>
+        <p:nvSpPr>
+          <p:cNvPr id="55" name="Text 53"/>
+          <p:cNvSpPr/>
+          <p:nvPr/>
+        </p:nvSpPr>
+        <p:spPr>
+          <a:xfrm>
+            <a:off x="493776" y="4361688"/>
+            <a:ext cx="2212848" cy="347472"/>
+          </a:xfrm>
+          <a:prstGeom prst="rect">
+            <a:avLst/>
+          </a:prstGeom>
+          <a:noFill/>
+          <a:ln/>
+        </p:spPr>
+        <p:txBody>
+          <a:bodyPr wrap="square" lIns="0" tIns="0" rIns="0" bIns="0" rtlCol="0" anchor="ctr"/>
+          <a:lstStyle/>
+          <a:p>
+            <a:pPr indent="0" marL="0">
+              <a:buNone/>
+            </a:pPr>
+            <a:r>
+              <a:rPr lang="en-US" sz="900" dirty="0">
+                <a:solidFill>
+                  <a:srgbClr val="0F172A"/>
+                </a:solidFill>
+                <a:latin typeface="Calibri" pitchFamily="34" charset="0"/>
+                <a:ea typeface="Calibri" pitchFamily="34" charset="-122"/>
+                <a:cs typeface="Calibri" pitchFamily="34" charset="-120"/>
+              </a:rPr>
+              <a:t>Lapsed Customer</a:t>
+            </a:r>
+            <a:endParaRPr lang="en-US" sz="900" dirty="0"/>
+          </a:p>
+        </p:txBody>
+      </p:sp>
+      <p:sp>
+        <p:nvSpPr>
+          <p:cNvPr id="56" name="Shape 54"/>
+          <p:cNvSpPr/>
+          <p:nvPr/>
+        </p:nvSpPr>
+        <p:spPr>
+          <a:xfrm>
+            <a:off x="2788920" y="4361688"/>
+            <a:ext cx="2194560" cy="347472"/>
+          </a:xfrm>
+          <a:prstGeom prst="rect">
+            <a:avLst/>
+          </a:prstGeom>
+          <a:solidFill>
+            <a:srgbClr val="F8FAFC"/>
+          </a:solidFill>
+          <a:ln w="12700">
+            <a:solidFill>
+              <a:srgbClr val="E2E8F0"/>
+            </a:solidFill>
+            <a:prstDash val="solid"/>
+          </a:ln>
+        </p:spPr>
+      </p:sp>
+      <p:sp>
+        <p:nvSpPr>
+          <p:cNvPr id="57" name="Text 55"/>
+          <p:cNvSpPr/>
+          <p:nvPr/>
+        </p:nvSpPr>
+        <p:spPr>
+          <a:xfrm>
+            <a:off x="2862072" y="4361688"/>
+            <a:ext cx="2084832" cy="347472"/>
+          </a:xfrm>
+          <a:prstGeom prst="rect">
+            <a:avLst/>
+          </a:prstGeom>
+          <a:noFill/>
+          <a:ln/>
+        </p:spPr>
+        <p:txBody>
+          <a:bodyPr wrap="square" lIns="0" tIns="0" rIns="0" bIns="0" rtlCol="0" anchor="ctr"/>
+          <a:lstStyle/>
+          <a:p>
+            <a:pPr indent="0" marL="0">
+              <a:buNone/>
+            </a:pPr>
+            <a:r>
+              <a:rPr lang="en-US" sz="950" b="1" dirty="0">
+                <a:solidFill>
+                  <a:srgbClr val="475569"/>
+                </a:solidFill>
+                <a:latin typeface="Calibri" pitchFamily="34" charset="0"/>
+                <a:ea typeface="Calibri" pitchFamily="34" charset="-122"/>
+                <a:cs typeface="Calibri" pitchFamily="34" charset="-120"/>
+              </a:rPr>
+              <a:t>Welcome Back — 1,000 Points</a:t>
+            </a:r>
+            <a:endParaRPr lang="en-US" sz="950" dirty="0"/>
+          </a:p>
+        </p:txBody>
+      </p:sp>
+      <p:sp>
+        <p:nvSpPr>
+          <p:cNvPr id="58" name="Shape 56"/>
+          <p:cNvSpPr/>
+          <p:nvPr/>
+        </p:nvSpPr>
+        <p:spPr>
+          <a:xfrm>
+            <a:off x="5029200" y="4361688"/>
+            <a:ext cx="3246120" cy="347472"/>
+          </a:xfrm>
+          <a:prstGeom prst="rect">
+            <a:avLst/>
+          </a:prstGeom>
+          <a:solidFill>
+            <a:srgbClr val="F8FAFC"/>
+          </a:solidFill>
+          <a:ln w="12700">
+            <a:solidFill>
+              <a:srgbClr val="E2E8F0"/>
+            </a:solidFill>
+            <a:prstDash val="solid"/>
+          </a:ln>
+        </p:spPr>
+      </p:sp>
+      <p:sp>
+        <p:nvSpPr>
+          <p:cNvPr id="59" name="Text 57"/>
+          <p:cNvSpPr/>
+          <p:nvPr/>
+        </p:nvSpPr>
+        <p:spPr>
+          <a:xfrm>
+            <a:off x="5102352" y="4361688"/>
+            <a:ext cx="3136392" cy="347472"/>
+          </a:xfrm>
+          <a:prstGeom prst="rect">
+            <a:avLst/>
+          </a:prstGeom>
+          <a:noFill/>
+          <a:ln/>
+        </p:spPr>
+        <p:txBody>
+          <a:bodyPr wrap="square" lIns="0" tIns="0" rIns="0" bIns="0" rtlCol="0" anchor="ctr"/>
+          <a:lstStyle/>
+          <a:p>
+            <a:pPr indent="0" marL="0">
+              <a:buNone/>
+            </a:pPr>
+            <a:r>
+              <a:rPr lang="en-US" sz="900" dirty="0">
+                <a:solidFill>
+                  <a:srgbClr val="475569"/>
+                </a:solidFill>
+                <a:latin typeface="Calibri" pitchFamily="34" charset="0"/>
+                <a:ea typeface="Calibri" pitchFamily="34" charset="-122"/>
+                <a:cs typeface="Calibri" pitchFamily="34" charset="-120"/>
+              </a:rPr>
+              <a:t>Win-back card with 60-day expiry</a:t>
+            </a:r>
+            <a:endParaRPr lang="en-US" sz="900" dirty="0"/>
+          </a:p>
+        </p:txBody>
+      </p:sp>
+      <p:sp>
+        <p:nvSpPr>
+          <p:cNvPr id="60" name="Text 58"/>
+          <p:cNvSpPr/>
+          <p:nvPr/>
+        </p:nvSpPr>
+        <p:spPr>
+          <a:xfrm>
+            <a:off x="365760" y="4690872"/>
+            <a:ext cx="8412480" cy="292608"/>
           </a:xfrm>
           <a:prstGeom prst="rect">
             <a:avLst/>
@@ -14427,132 +16727,15 @@
               <a:buNone/>
             </a:pPr>
             <a:r>
-              <a:rPr lang="en-US" sz="750" b="1" dirty="0">
-                <a:solidFill>
-                  <a:srgbClr val="FFFFFF"/>
-                </a:solidFill>
-                <a:latin typeface="Calibri" pitchFamily="34" charset="0"/>
-                <a:ea typeface="Calibri" pitchFamily="34" charset="-122"/>
-                <a:cs typeface="Calibri" pitchFamily="34" charset="-120"/>
-              </a:rPr>
-              <a:t>Site D</a:t>
-            </a:r>
-            <a:endParaRPr lang="en-US" sz="750" dirty="0"/>
-          </a:p>
-        </p:txBody>
-      </p:sp>
-      <p:sp>
-        <p:nvSpPr>
-          <p:cNvPr id="28" name="Text 26"/>
-          <p:cNvSpPr/>
-          <p:nvPr/>
-        </p:nvSpPr>
-        <p:spPr>
-          <a:xfrm>
-            <a:off x="5257800" y="2971800"/>
-            <a:ext cx="3383280" cy="384048"/>
-          </a:xfrm>
-          <a:prstGeom prst="rect">
-            <a:avLst/>
-          </a:prstGeom>
-          <a:noFill/>
-          <a:ln/>
-        </p:spPr>
-        <p:txBody>
-          <a:bodyPr wrap="square" lIns="0" tIns="0" rIns="0" bIns="0" rtlCol="0" anchor="ctr"/>
-          <a:lstStyle/>
-          <a:p>
-            <a:pPr indent="0" marL="0">
-              <a:buNone/>
-            </a:pPr>
-            <a:r>
-              <a:rPr lang="en-US" sz="1300" b="1" dirty="0">
-                <a:solidFill>
-                  <a:srgbClr val="0F172A"/>
-                </a:solidFill>
-                <a:latin typeface="Calibri" pitchFamily="34" charset="0"/>
-                <a:ea typeface="Calibri" pitchFamily="34" charset="-122"/>
-                <a:cs typeface="Calibri" pitchFamily="34" charset="-120"/>
-              </a:rPr>
-              <a:t>🖥️  Nexus CDP Platform</a:t>
-            </a:r>
-            <a:endParaRPr lang="en-US" sz="1300" dirty="0"/>
-          </a:p>
-        </p:txBody>
-      </p:sp>
-      <p:sp>
-        <p:nvSpPr>
-          <p:cNvPr id="29" name="Text 27"/>
-          <p:cNvSpPr/>
-          <p:nvPr/>
-        </p:nvSpPr>
-        <p:spPr>
-          <a:xfrm>
-            <a:off x="5257800" y="3355848"/>
-            <a:ext cx="3383280" cy="256032"/>
-          </a:xfrm>
-          <a:prstGeom prst="rect">
-            <a:avLst/>
-          </a:prstGeom>
-          <a:noFill/>
-          <a:ln/>
-        </p:spPr>
-        <p:txBody>
-          <a:bodyPr wrap="square" lIns="0" tIns="0" rIns="0" bIns="0" rtlCol="0" anchor="ctr"/>
-          <a:lstStyle/>
-          <a:p>
-            <a:pPr indent="0" marL="0">
-              <a:buNone/>
-            </a:pPr>
-            <a:r>
-              <a:rPr lang="en-US" sz="950" dirty="0">
-                <a:solidFill>
-                  <a:srgbClr val="8B5CF6"/>
-                </a:solidFill>
-                <a:latin typeface="Consolas" pitchFamily="34" charset="0"/>
-                <a:ea typeface="Consolas" pitchFamily="34" charset="-122"/>
-                <a:cs typeface="Consolas" pitchFamily="34" charset="-120"/>
-              </a:rPr>
-              <a:t>localhost:3004</a:t>
-            </a:r>
-            <a:endParaRPr lang="en-US" sz="950" dirty="0"/>
-          </a:p>
-        </p:txBody>
-      </p:sp>
-      <p:sp>
-        <p:nvSpPr>
-          <p:cNvPr id="30" name="Text 28"/>
-          <p:cNvSpPr/>
-          <p:nvPr/>
-        </p:nvSpPr>
-        <p:spPr>
-          <a:xfrm>
-            <a:off x="4800600" y="3657600"/>
-            <a:ext cx="3840480" cy="594360"/>
-          </a:xfrm>
-          <a:prstGeom prst="rect">
-            <a:avLst/>
-          </a:prstGeom>
-          <a:noFill/>
-          <a:ln/>
-        </p:spPr>
-        <p:txBody>
-          <a:bodyPr wrap="square" lIns="0" tIns="0" rIns="0" bIns="0" rtlCol="0" anchor="ctr"/>
-          <a:lstStyle/>
-          <a:p>
-            <a:pPr indent="0" marL="0">
-              <a:buNone/>
-            </a:pPr>
-            <a:r>
-              <a:rPr lang="en-US" sz="1050" dirty="0">
-                <a:solidFill>
-                  <a:srgbClr val="475569"/>
-                </a:solidFill>
-                <a:latin typeface="Calibri" pitchFamily="34" charset="0"/>
-                <a:ea typeface="Calibri" pitchFamily="34" charset="-122"/>
-                <a:cs typeface="Calibri" pitchFamily="34" charset="-120"/>
-              </a:rPr>
-              <a:t>Live profile explorer, event stream, signal builder, and webhook manager</a:t>
+              <a:rPr lang="en-US" sz="1050" i="1" dirty="0">
+                <a:solidFill>
+                  <a:srgbClr val="6366F1"/>
+                </a:solidFill>
+                <a:latin typeface="Calibri" pitchFamily="34" charset="0"/>
+                <a:ea typeface="Calibri" pitchFamily="34" charset="-122"/>
+                <a:cs typeface="Calibri" pitchFamily="34" charset="-120"/>
+              </a:rPr>
+              <a:t>One active offer per signal per profile — fire_count increments on repeat firings; no duplicates.</a:t>
             </a:r>
             <a:endParaRPr lang="en-US" sz="1050" dirty="0"/>
           </a:p>
@@ -14560,46 +16743,7 @@
       </p:sp>
       <p:sp>
         <p:nvSpPr>
-          <p:cNvPr id="31" name="Text 29"/>
-          <p:cNvSpPr/>
-          <p:nvPr/>
-        </p:nvSpPr>
-        <p:spPr>
-          <a:xfrm>
-            <a:off x="365760" y="4553712"/>
-            <a:ext cx="8412480" cy="320040"/>
-          </a:xfrm>
-          <a:prstGeom prst="rect">
-            <a:avLst/>
-          </a:prstGeom>
-          <a:noFill/>
-          <a:ln/>
-        </p:spPr>
-        <p:txBody>
-          <a:bodyPr wrap="square" lIns="0" tIns="0" rIns="0" bIns="0" rtlCol="0" anchor="ctr"/>
-          <a:lstStyle/>
-          <a:p>
-            <a:pPr algn="ctr" indent="0" marL="0">
-              <a:buNone/>
-            </a:pPr>
-            <a:r>
-              <a:rPr lang="en-US" sz="1200" i="1" dirty="0">
-                <a:solidFill>
-                  <a:srgbClr val="6366F1"/>
-                </a:solidFill>
-                <a:latin typeface="Calibri" pitchFamily="34" charset="0"/>
-                <a:ea typeface="Calibri" pitchFamily="34" charset="-122"/>
-                <a:cs typeface="Calibri" pitchFamily="34" charset="-120"/>
-              </a:rPr>
-              <a:t>All four sites share one CDP.  Watch the same customer recognized across every touchpoint.</a:t>
-            </a:r>
-            <a:endParaRPr lang="en-US" sz="1200" dirty="0"/>
-          </a:p>
-        </p:txBody>
-      </p:sp>
-      <p:sp>
-        <p:nvSpPr>
-          <p:cNvPr id="32" name="Shape 30"/>
+          <p:cNvPr id="61" name="Shape 59"/>
           <p:cNvSpPr/>
           <p:nvPr/>
         </p:nvSpPr>
@@ -14624,7 +16768,7 @@
       </p:sp>
       <p:sp>
         <p:nvSpPr>
-          <p:cNvPr id="33" name="Text 31"/>
+          <p:cNvPr id="62" name="Text 60"/>
           <p:cNvSpPr/>
           <p:nvPr/>
         </p:nvSpPr>
@@ -14663,7 +16807,7 @@
       </p:sp>
       <p:sp>
         <p:nvSpPr>
-          <p:cNvPr id="34" name="Text 32"/>
+          <p:cNvPr id="63" name="Text 61"/>
           <p:cNvSpPr/>
           <p:nvPr/>
         </p:nvSpPr>
@@ -14702,7 +16846,7 @@
       </p:sp>
       <p:sp>
         <p:nvSpPr>
-          <p:cNvPr id="35" name="Text 33"/>
+          <p:cNvPr id="64" name="Text 62"/>
           <p:cNvSpPr/>
           <p:nvPr/>
         </p:nvSpPr>

</xml_diff>

<commit_message>
feat: add public Railway URLs to Demo Guide and PowerPoint
- Demo Guide page: live app link strip (4 clickable cards) at the top
  linking to each production site; trigger "where" labels now link
  directly to the relevant app
- PowerPoint slide 10: replace localhost ports with production
  Railway hostnames for all 4 sites

Co-Authored-By: Claude Sonnet 4.6 <noreply@anthropic.com>
</commit_message>
<xml_diff>
--- a/docs/business-proposal.pptx
+++ b/docs/business-proposal.pptx
@@ -2595,7 +2595,7 @@
               <a:buNone/>
             </a:pPr>
             <a:r>
-              <a:rPr lang="en-US" sz="950" dirty="0">
+              <a:rPr lang="en-US" sz="850" dirty="0">
                 <a:solidFill>
                   <a:srgbClr val="6366F1"/>
                 </a:solidFill>
@@ -2603,9 +2603,9 @@
                 <a:ea typeface="Consolas" pitchFamily="34" charset="-122"/>
                 <a:cs typeface="Consolas" pitchFamily="34" charset="-120"/>
               </a:rPr>
-              <a:t>localhost:3001</a:t>
-            </a:r>
-            <a:endParaRPr lang="en-US" sz="950" dirty="0"/>
+              <a:t>nexus-cdp-storefront-production.up.railway.app</a:t>
+            </a:r>
+            <a:endParaRPr lang="en-US" sz="850" dirty="0"/>
           </a:p>
         </p:txBody>
       </p:sp>
@@ -2833,7 +2833,7 @@
               <a:buNone/>
             </a:pPr>
             <a:r>
-              <a:rPr lang="en-US" sz="950" dirty="0">
+              <a:rPr lang="en-US" sz="850" dirty="0">
                 <a:solidFill>
                   <a:srgbClr val="F59E0B"/>
                 </a:solidFill>
@@ -2841,9 +2841,9 @@
                 <a:ea typeface="Consolas" pitchFamily="34" charset="-122"/>
                 <a:cs typeface="Consolas" pitchFamily="34" charset="-120"/>
               </a:rPr>
-              <a:t>localhost:3002</a:t>
-            </a:r>
-            <a:endParaRPr lang="en-US" sz="950" dirty="0"/>
+              <a:t>nexus-cdp-loyalty-production.up.railway.app</a:t>
+            </a:r>
+            <a:endParaRPr lang="en-US" sz="850" dirty="0"/>
           </a:p>
         </p:txBody>
       </p:sp>
@@ -3071,7 +3071,7 @@
               <a:buNone/>
             </a:pPr>
             <a:r>
-              <a:rPr lang="en-US" sz="950" dirty="0">
+              <a:rPr lang="en-US" sz="850" dirty="0">
                 <a:solidFill>
                   <a:srgbClr val="10B981"/>
                 </a:solidFill>
@@ -3079,9 +3079,9 @@
                 <a:ea typeface="Consolas" pitchFamily="34" charset="-122"/>
                 <a:cs typeface="Consolas" pitchFamily="34" charset="-120"/>
               </a:rPr>
-              <a:t>localhost:3003</a:t>
-            </a:r>
-            <a:endParaRPr lang="en-US" sz="950" dirty="0"/>
+              <a:t>nexus-cdp-telemetry-production.up.railway.app</a:t>
+            </a:r>
+            <a:endParaRPr lang="en-US" sz="850" dirty="0"/>
           </a:p>
         </p:txBody>
       </p:sp>
@@ -3309,7 +3309,7 @@
               <a:buNone/>
             </a:pPr>
             <a:r>
-              <a:rPr lang="en-US" sz="950" dirty="0">
+              <a:rPr lang="en-US" sz="850" dirty="0">
                 <a:solidFill>
                   <a:srgbClr val="8B5CF6"/>
                 </a:solidFill>
@@ -3317,9 +3317,9 @@
                 <a:ea typeface="Consolas" pitchFamily="34" charset="-122"/>
                 <a:cs typeface="Consolas" pitchFamily="34" charset="-120"/>
               </a:rPr>
-              <a:t>localhost:3004</a:t>
-            </a:r>
-            <a:endParaRPr lang="en-US" sz="950" dirty="0"/>
+              <a:t>nexus-cdp-platform-production.up.railway.app</a:t>
+            </a:r>
+            <a:endParaRPr lang="en-US" sz="850" dirty="0"/>
           </a:p>
         </p:txBody>
       </p:sp>

</xml_diff>